<commit_message>
slides: add "Connecting users: SAML vs built-in" slide (Activity #2)
New slide 7 mirrors ACTIVITY-2-AUTH.md: a side-by-side of built-in vs SAML
(organization-specific) logins, with the takeaway that both use the same
OAuth 2.0 flow and code — only VITE_PORTAL_URL changes. Deck is now 11 slides
(footers auto-number, so no manual renumbering needed).

Co-Authored-By: Claude Opus 4.8 <noreply@anthropic.com>
</commit_message>
<xml_diff>
--- a/docs/slides/ArcGIS-AI-Components-Walkthrough.pptx
+++ b/docs/slides/ArcGIS-AI-Components-Walkthrough.pptx
@@ -15,9 +15,10 @@
     <p:sldId id="263" r:id="rId9"/>
     <p:sldId id="264" r:id="rId10"/>
     <p:sldId id="265" r:id="rId11"/>
+    <p:sldId id="266" r:id="rId12"/>
   </p:sldIdLst>
   <p:notesMasterIdLst>
-    <p:notesMasterId r:id="rId12"/>
+    <p:notesMasterId r:id="rId13"/>
   </p:notesMasterIdLst>
   <p:sldSz cx="12191695" cy="6858000"/>
   <p:notesSz cx="6858000" cy="12191695"/>
@@ -623,6 +624,94 @@
             <a:fld id="{F7021451-1387-4CA6-816F-3879F97B5CBC}" type="slidenum">
               <a:rPr lang="en-US"/>
               <a:t>10</a:t>
+            </a:fld>
+            <a:endParaRPr lang="en-US"/>
+          </a:p>
+        </p:txBody>
+      </p:sp>
+    </p:spTree>
+    <p:extLst>
+      <p:ext uri="{BB962C8B-B14F-4D97-AF65-F5344CB8AC3E}">
+        <p14:creationId xmlns:p14="http://schemas.microsoft.com/office/powerpoint/2010/main" val="1024086991"/>
+      </p:ext>
+    </p:extLst>
+  </p:cSld>
+  <p:clrMapOvr>
+    <a:masterClrMapping/>
+  </p:clrMapOvr>
+</p:notes>
+</file>
+
+<file path=ppt/notesSlides/notesSlide11.xml><?xml version="1.0" encoding="utf-8"?>
+<p:notes xmlns:a="http://schemas.openxmlformats.org/drawingml/2006/main" xmlns:r="http://schemas.openxmlformats.org/officeDocument/2006/relationships" xmlns:p="http://schemas.openxmlformats.org/presentationml/2006/main">
+  <p:cSld>
+    <p:spTree>
+      <p:nvGrpSpPr>
+        <p:cNvPr id="1" name=""/>
+        <p:cNvGrpSpPr/>
+        <p:nvPr/>
+      </p:nvGrpSpPr>
+      <p:grpSpPr>
+        <a:xfrm>
+          <a:off x="0" y="0"/>
+          <a:ext cx="0" cy="0"/>
+          <a:chOff x="0" y="0"/>
+          <a:chExt cx="0" cy="0"/>
+        </a:xfrm>
+      </p:grpSpPr>
+      <p:sp>
+        <p:nvSpPr>
+          <p:cNvPr id="2" name="Slide Image Placeholder 1"/>
+          <p:cNvSpPr>
+            <a:spLocks noGrp="1" noRot="1" noChangeAspect="1"/>
+          </p:cNvSpPr>
+          <p:nvPr>
+            <p:ph type="sldImg"/>
+          </p:nvPr>
+        </p:nvSpPr>
+        <p:spPr/>
+      </p:sp>
+      <p:sp>
+        <p:nvSpPr>
+          <p:cNvPr id="3" name="Notes Placeholder 2"/>
+          <p:cNvSpPr>
+            <a:spLocks noGrp="1"/>
+          </p:cNvSpPr>
+          <p:nvPr>
+            <p:ph type="body" idx="1"/>
+          </p:nvPr>
+        </p:nvSpPr>
+        <p:spPr/>
+        <p:txBody>
+          <a:bodyPr/>
+          <a:lstStyle/>
+          <a:p>
+            <a:r>
+              <a:rPr lang="en-US" dirty="0"/>
+              <a:t/>
+            </a:r>
+            <a:endParaRPr lang="en-US" dirty="0"/>
+          </a:p>
+        </p:txBody>
+      </p:sp>
+      <p:sp>
+        <p:nvSpPr>
+          <p:cNvPr id="4" name="Slide Number Placeholder 3"/>
+          <p:cNvSpPr>
+            <a:spLocks noGrp="1"/>
+          </p:cNvSpPr>
+          <p:nvPr>
+            <p:ph type="sldNum" sz="quarter" idx="10"/>
+          </p:nvPr>
+        </p:nvSpPr>
+        <p:spPr/>
+        <p:txBody>
+          <a:bodyPr/>
+          <a:lstStyle/>
+          <a:p>
+            <a:fld id="{F7021451-1387-4CA6-816F-3879F97B5CBC}" type="slidenum">
+              <a:rPr lang="en-US"/>
+              <a:t>11</a:t>
             </a:fld>
             <a:endParaRPr lang="en-US"/>
           </a:p>
@@ -1952,6 +2041,858 @@
     <p:bg>
       <p:bgPr>
         <a:solidFill>
+          <a:srgbClr val="FFFFFF"/>
+        </a:solidFill>
+      </p:bgPr>
+    </p:bg>
+    <p:spTree>
+      <p:nvGrpSpPr>
+        <p:cNvPr id="1" name=""/>
+        <p:cNvGrpSpPr/>
+        <p:nvPr/>
+      </p:nvGrpSpPr>
+      <p:grpSpPr>
+        <a:xfrm>
+          <a:off x="0" y="0"/>
+          <a:ext cx="0" cy="0"/>
+          <a:chOff x="0" y="0"/>
+          <a:chExt cx="0" cy="0"/>
+        </a:xfrm>
+      </p:grpSpPr>
+      <p:sp>
+        <p:nvSpPr>
+          <p:cNvPr id="2" name="Text 0"/>
+          <p:cNvSpPr/>
+          <p:nvPr/>
+        </p:nvSpPr>
+        <p:spPr>
+          <a:xfrm>
+            <a:off x="502920" y="411480"/>
+            <a:ext cx="11155680" cy="640080"/>
+          </a:xfrm>
+          <a:prstGeom prst="rect">
+            <a:avLst/>
+          </a:prstGeom>
+          <a:noFill/>
+          <a:ln/>
+        </p:spPr>
+        <p:txBody>
+          <a:bodyPr wrap="square" lIns="0" tIns="0" rIns="0" bIns="0" rtlCol="0" anchor="ctr"/>
+          <a:lstStyle/>
+          <a:p>
+            <a:pPr indent="0" marL="0">
+              <a:buNone/>
+            </a:pPr>
+            <a:r>
+              <a:rPr lang="en-US" sz="3000" b="1" dirty="0">
+                <a:solidFill>
+                  <a:srgbClr val="0B2545"/>
+                </a:solidFill>
+                <a:latin typeface="Bookman Old Style" pitchFamily="34" charset="0"/>
+                <a:ea typeface="Bookman Old Style" pitchFamily="34" charset="-122"/>
+                <a:cs typeface="Bookman Old Style" pitchFamily="34" charset="-120"/>
+              </a:rPr>
+              <a:t>The demo run sheet — prompt shapes that work</a:t>
+            </a:r>
+            <a:endParaRPr lang="en-US" sz="3000" dirty="0"/>
+          </a:p>
+        </p:txBody>
+      </p:sp>
+      <p:sp>
+        <p:nvSpPr>
+          <p:cNvPr id="3" name="Text 1"/>
+          <p:cNvSpPr/>
+          <p:nvPr/>
+        </p:nvSpPr>
+        <p:spPr>
+          <a:xfrm>
+            <a:off x="502920" y="1078992"/>
+            <a:ext cx="10972800" cy="457200"/>
+          </a:xfrm>
+          <a:prstGeom prst="rect">
+            <a:avLst/>
+          </a:prstGeom>
+          <a:noFill/>
+          <a:ln/>
+        </p:spPr>
+        <p:txBody>
+          <a:bodyPr wrap="square" lIns="0" tIns="0" rIns="0" bIns="0" rtlCol="0" anchor="ctr"/>
+          <a:lstStyle/>
+          <a:p>
+            <a:pPr indent="0" marL="0">
+              <a:buNone/>
+            </a:pPr>
+            <a:r>
+              <a:rPr lang="en-US" sz="1400" dirty="0">
+                <a:solidFill>
+                  <a:srgbClr val="5B6B7F"/>
+                </a:solidFill>
+                <a:latin typeface="Calibri" pitchFamily="34" charset="0"/>
+                <a:ea typeface="Calibri" pitchFamily="34" charset="-122"/>
+                <a:cs typeface="Calibri" pitchFamily="34" charset="-120"/>
+              </a:rPr>
+              <a:t>Fill these with prompts you've verified against your data. Build from simple to the strongest hook.</a:t>
+            </a:r>
+            <a:endParaRPr lang="en-US" sz="1400" dirty="0"/>
+          </a:p>
+        </p:txBody>
+      </p:sp>
+      <p:sp>
+        <p:nvSpPr>
+          <p:cNvPr id="4" name="Shape 2"/>
+          <p:cNvSpPr/>
+          <p:nvPr/>
+        </p:nvSpPr>
+        <p:spPr>
+          <a:xfrm>
+            <a:off x="502920" y="1783080"/>
+            <a:ext cx="11201400" cy="932688"/>
+          </a:xfrm>
+          <a:prstGeom prst="roundRect">
+            <a:avLst>
+              <a:gd name="adj" fmla="val 7843"/>
+            </a:avLst>
+          </a:prstGeom>
+          <a:solidFill>
+            <a:srgbClr val="F4F7FA"/>
+          </a:solidFill>
+          <a:ln/>
+          <a:effectLst>
+            <a:outerShdw sx="100000" sy="100000" kx="0" ky="0" algn="bl" rotWithShape="0" blurRad="88900" dist="38100" dir="5400000">
+              <a:srgbClr val="000000">
+                <a:alpha val="12000"/>
+              </a:srgbClr>
+            </a:outerShdw>
+          </a:effectLst>
+        </p:spPr>
+      </p:sp>
+      <p:sp>
+        <p:nvSpPr>
+          <p:cNvPr id="5" name="Shape 3"/>
+          <p:cNvSpPr/>
+          <p:nvPr/>
+        </p:nvSpPr>
+        <p:spPr>
+          <a:xfrm>
+            <a:off x="731520" y="1984248"/>
+            <a:ext cx="566928" cy="566928"/>
+          </a:xfrm>
+          <a:prstGeom prst="ellipse">
+            <a:avLst/>
+          </a:prstGeom>
+          <a:solidFill>
+            <a:srgbClr val="1C7293"/>
+          </a:solidFill>
+          <a:ln/>
+        </p:spPr>
+      </p:sp>
+      <p:sp>
+        <p:nvSpPr>
+          <p:cNvPr id="6" name="Text 4"/>
+          <p:cNvSpPr/>
+          <p:nvPr/>
+        </p:nvSpPr>
+        <p:spPr>
+          <a:xfrm>
+            <a:off x="731520" y="1984248"/>
+            <a:ext cx="566928" cy="566928"/>
+          </a:xfrm>
+          <a:prstGeom prst="rect">
+            <a:avLst/>
+          </a:prstGeom>
+          <a:noFill/>
+          <a:ln/>
+        </p:spPr>
+        <p:txBody>
+          <a:bodyPr wrap="square" lIns="0" tIns="0" rIns="0" bIns="0" rtlCol="0" anchor="ctr"/>
+          <a:lstStyle/>
+          <a:p>
+            <a:pPr algn="ctr" indent="0" marL="0">
+              <a:buNone/>
+            </a:pPr>
+            <a:r>
+              <a:rPr lang="en-US" sz="1800" b="1" dirty="0">
+                <a:solidFill>
+                  <a:srgbClr val="FFFFFF"/>
+                </a:solidFill>
+                <a:latin typeface="Calibri" pitchFamily="34" charset="0"/>
+                <a:ea typeface="Calibri" pitchFamily="34" charset="-122"/>
+                <a:cs typeface="Calibri" pitchFamily="34" charset="-120"/>
+              </a:rPr>
+              <a:t>1</a:t>
+            </a:r>
+            <a:endParaRPr lang="en-US" sz="1800" dirty="0"/>
+          </a:p>
+        </p:txBody>
+      </p:sp>
+      <p:sp>
+        <p:nvSpPr>
+          <p:cNvPr id="7" name="Text 5"/>
+          <p:cNvSpPr/>
+          <p:nvPr/>
+        </p:nvSpPr>
+        <p:spPr>
+          <a:xfrm>
+            <a:off x="1508760" y="1892808"/>
+            <a:ext cx="10058400" cy="438912"/>
+          </a:xfrm>
+          <a:prstGeom prst="rect">
+            <a:avLst/>
+          </a:prstGeom>
+          <a:noFill/>
+          <a:ln/>
+        </p:spPr>
+        <p:txBody>
+          <a:bodyPr wrap="square" lIns="0" tIns="0" rIns="0" bIns="0" rtlCol="0" anchor="ctr"/>
+          <a:lstStyle/>
+          <a:p>
+            <a:pPr indent="0" marL="0">
+              <a:buNone/>
+            </a:pPr>
+            <a:r>
+              <a:rPr lang="en-US" sz="1550" b="1" dirty="0">
+                <a:solidFill>
+                  <a:srgbClr val="0B2545"/>
+                </a:solidFill>
+                <a:latin typeface="Calibri" pitchFamily="34" charset="0"/>
+                <a:ea typeface="Calibri" pitchFamily="34" charset="-122"/>
+                <a:cs typeface="Calibri" pitchFamily="34" charset="-120"/>
+              </a:rPr>
+              <a:t>"Show me the &lt;high-priority&gt; &lt;records&gt;."</a:t>
+            </a:r>
+            <a:endParaRPr lang="en-US" sz="1550" dirty="0"/>
+          </a:p>
+        </p:txBody>
+      </p:sp>
+      <p:sp>
+        <p:nvSpPr>
+          <p:cNvPr id="8" name="Text 6"/>
+          <p:cNvSpPr/>
+          <p:nvPr/>
+        </p:nvSpPr>
+        <p:spPr>
+          <a:xfrm>
+            <a:off x="1508760" y="2286000"/>
+            <a:ext cx="10058400" cy="384048"/>
+          </a:xfrm>
+          <a:prstGeom prst="rect">
+            <a:avLst/>
+          </a:prstGeom>
+          <a:noFill/>
+          <a:ln/>
+        </p:spPr>
+        <p:txBody>
+          <a:bodyPr wrap="square" lIns="0" tIns="0" rIns="0" bIns="0" rtlCol="0" anchor="ctr"/>
+          <a:lstStyle/>
+          <a:p>
+            <a:pPr indent="0" marL="0">
+              <a:buNone/>
+            </a:pPr>
+            <a:r>
+              <a:rPr lang="en-US" sz="1250" dirty="0">
+                <a:solidFill>
+                  <a:srgbClr val="5B6B7F"/>
+                </a:solidFill>
+                <a:latin typeface="Calibri" pitchFamily="34" charset="0"/>
+                <a:ea typeface="Calibri" pitchFamily="34" charset="-122"/>
+                <a:cs typeface="Calibri" pitchFamily="34" charset="-120"/>
+              </a:rPr>
+              <a:t>Opener — single-attribute filter. Verify the count is stable.</a:t>
+            </a:r>
+            <a:endParaRPr lang="en-US" sz="1250" dirty="0"/>
+          </a:p>
+        </p:txBody>
+      </p:sp>
+      <p:sp>
+        <p:nvSpPr>
+          <p:cNvPr id="9" name="Shape 7"/>
+          <p:cNvSpPr/>
+          <p:nvPr/>
+        </p:nvSpPr>
+        <p:spPr>
+          <a:xfrm>
+            <a:off x="502920" y="2862072"/>
+            <a:ext cx="11201400" cy="932688"/>
+          </a:xfrm>
+          <a:prstGeom prst="roundRect">
+            <a:avLst>
+              <a:gd name="adj" fmla="val 7843"/>
+            </a:avLst>
+          </a:prstGeom>
+          <a:solidFill>
+            <a:srgbClr val="F4F7FA"/>
+          </a:solidFill>
+          <a:ln/>
+          <a:effectLst>
+            <a:outerShdw sx="100000" sy="100000" kx="0" ky="0" algn="bl" rotWithShape="0" blurRad="88900" dist="38100" dir="5400000">
+              <a:srgbClr val="000000">
+                <a:alpha val="12000"/>
+              </a:srgbClr>
+            </a:outerShdw>
+          </a:effectLst>
+        </p:spPr>
+      </p:sp>
+      <p:sp>
+        <p:nvSpPr>
+          <p:cNvPr id="10" name="Shape 8"/>
+          <p:cNvSpPr/>
+          <p:nvPr/>
+        </p:nvSpPr>
+        <p:spPr>
+          <a:xfrm>
+            <a:off x="731520" y="3063240"/>
+            <a:ext cx="566928" cy="566928"/>
+          </a:xfrm>
+          <a:prstGeom prst="ellipse">
+            <a:avLst/>
+          </a:prstGeom>
+          <a:solidFill>
+            <a:srgbClr val="1C7293"/>
+          </a:solidFill>
+          <a:ln/>
+        </p:spPr>
+      </p:sp>
+      <p:sp>
+        <p:nvSpPr>
+          <p:cNvPr id="11" name="Text 9"/>
+          <p:cNvSpPr/>
+          <p:nvPr/>
+        </p:nvSpPr>
+        <p:spPr>
+          <a:xfrm>
+            <a:off x="731520" y="3063240"/>
+            <a:ext cx="566928" cy="566928"/>
+          </a:xfrm>
+          <a:prstGeom prst="rect">
+            <a:avLst/>
+          </a:prstGeom>
+          <a:noFill/>
+          <a:ln/>
+        </p:spPr>
+        <p:txBody>
+          <a:bodyPr wrap="square" lIns="0" tIns="0" rIns="0" bIns="0" rtlCol="0" anchor="ctr"/>
+          <a:lstStyle/>
+          <a:p>
+            <a:pPr algn="ctr" indent="0" marL="0">
+              <a:buNone/>
+            </a:pPr>
+            <a:r>
+              <a:rPr lang="en-US" sz="1800" b="1" dirty="0">
+                <a:solidFill>
+                  <a:srgbClr val="FFFFFF"/>
+                </a:solidFill>
+                <a:latin typeface="Calibri" pitchFamily="34" charset="0"/>
+                <a:ea typeface="Calibri" pitchFamily="34" charset="-122"/>
+                <a:cs typeface="Calibri" pitchFamily="34" charset="-120"/>
+              </a:rPr>
+              <a:t>2</a:t>
+            </a:r>
+            <a:endParaRPr lang="en-US" sz="1800" dirty="0"/>
+          </a:p>
+        </p:txBody>
+      </p:sp>
+      <p:sp>
+        <p:nvSpPr>
+          <p:cNvPr id="12" name="Text 10"/>
+          <p:cNvSpPr/>
+          <p:nvPr/>
+        </p:nvSpPr>
+        <p:spPr>
+          <a:xfrm>
+            <a:off x="1508760" y="2971800"/>
+            <a:ext cx="10058400" cy="438912"/>
+          </a:xfrm>
+          <a:prstGeom prst="rect">
+            <a:avLst/>
+          </a:prstGeom>
+          <a:noFill/>
+          <a:ln/>
+        </p:spPr>
+        <p:txBody>
+          <a:bodyPr wrap="square" lIns="0" tIns="0" rIns="0" bIns="0" rtlCol="0" anchor="ctr"/>
+          <a:lstStyle/>
+          <a:p>
+            <a:pPr indent="0" marL="0">
+              <a:buNone/>
+            </a:pPr>
+            <a:r>
+              <a:rPr lang="en-US" sz="1550" b="1" dirty="0">
+                <a:solidFill>
+                  <a:srgbClr val="0B2545"/>
+                </a:solidFill>
+                <a:latin typeface="Calibri" pitchFamily="34" charset="0"/>
+                <a:ea typeface="Calibri" pitchFamily="34" charset="-122"/>
+                <a:cs typeface="Calibri" pitchFamily="34" charset="-120"/>
+              </a:rPr>
+              <a:t>"Average &lt;metric&gt; for &lt;one category&gt;?"</a:t>
+            </a:r>
+            <a:endParaRPr lang="en-US" sz="1550" dirty="0"/>
+          </a:p>
+        </p:txBody>
+      </p:sp>
+      <p:sp>
+        <p:nvSpPr>
+          <p:cNvPr id="13" name="Text 11"/>
+          <p:cNvSpPr/>
+          <p:nvPr/>
+        </p:nvSpPr>
+        <p:spPr>
+          <a:xfrm>
+            <a:off x="1508760" y="3364992"/>
+            <a:ext cx="10058400" cy="384048"/>
+          </a:xfrm>
+          <a:prstGeom prst="rect">
+            <a:avLst/>
+          </a:prstGeom>
+          <a:noFill/>
+          <a:ln/>
+        </p:spPr>
+        <p:txBody>
+          <a:bodyPr wrap="square" lIns="0" tIns="0" rIns="0" bIns="0" rtlCol="0" anchor="ctr"/>
+          <a:lstStyle/>
+          <a:p>
+            <a:pPr indent="0" marL="0">
+              <a:buNone/>
+            </a:pPr>
+            <a:r>
+              <a:rPr lang="en-US" sz="1250" dirty="0">
+                <a:solidFill>
+                  <a:srgbClr val="5B6B7F"/>
+                </a:solidFill>
+                <a:latin typeface="Calibri" pitchFamily="34" charset="0"/>
+                <a:ea typeface="Calibri" pitchFamily="34" charset="-122"/>
+                <a:cs typeface="Calibri" pitchFamily="34" charset="-120"/>
+              </a:rPr>
+              <a:t>Single-group stat. (Don't ask it to COMPARE two categories live.)</a:t>
+            </a:r>
+            <a:endParaRPr lang="en-US" sz="1250" dirty="0"/>
+          </a:p>
+        </p:txBody>
+      </p:sp>
+      <p:sp>
+        <p:nvSpPr>
+          <p:cNvPr id="14" name="Shape 12"/>
+          <p:cNvSpPr/>
+          <p:nvPr/>
+        </p:nvSpPr>
+        <p:spPr>
+          <a:xfrm>
+            <a:off x="502920" y="3941064"/>
+            <a:ext cx="11201400" cy="932688"/>
+          </a:xfrm>
+          <a:prstGeom prst="roundRect">
+            <a:avLst>
+              <a:gd name="adj" fmla="val 7843"/>
+            </a:avLst>
+          </a:prstGeom>
+          <a:solidFill>
+            <a:srgbClr val="F4F7FA"/>
+          </a:solidFill>
+          <a:ln/>
+          <a:effectLst>
+            <a:outerShdw sx="100000" sy="100000" kx="0" ky="0" algn="bl" rotWithShape="0" blurRad="88900" dist="38100" dir="5400000">
+              <a:srgbClr val="000000">
+                <a:alpha val="12000"/>
+              </a:srgbClr>
+            </a:outerShdw>
+          </a:effectLst>
+        </p:spPr>
+      </p:sp>
+      <p:sp>
+        <p:nvSpPr>
+          <p:cNvPr id="15" name="Shape 13"/>
+          <p:cNvSpPr/>
+          <p:nvPr/>
+        </p:nvSpPr>
+        <p:spPr>
+          <a:xfrm>
+            <a:off x="731520" y="4142232"/>
+            <a:ext cx="566928" cy="566928"/>
+          </a:xfrm>
+          <a:prstGeom prst="ellipse">
+            <a:avLst/>
+          </a:prstGeom>
+          <a:solidFill>
+            <a:srgbClr val="E8A33D"/>
+          </a:solidFill>
+          <a:ln/>
+        </p:spPr>
+      </p:sp>
+      <p:sp>
+        <p:nvSpPr>
+          <p:cNvPr id="16" name="Text 14"/>
+          <p:cNvSpPr/>
+          <p:nvPr/>
+        </p:nvSpPr>
+        <p:spPr>
+          <a:xfrm>
+            <a:off x="731520" y="4142232"/>
+            <a:ext cx="566928" cy="566928"/>
+          </a:xfrm>
+          <a:prstGeom prst="rect">
+            <a:avLst/>
+          </a:prstGeom>
+          <a:noFill/>
+          <a:ln/>
+        </p:spPr>
+        <p:txBody>
+          <a:bodyPr wrap="square" lIns="0" tIns="0" rIns="0" bIns="0" rtlCol="0" anchor="ctr"/>
+          <a:lstStyle/>
+          <a:p>
+            <a:pPr algn="ctr" indent="0" marL="0">
+              <a:buNone/>
+            </a:pPr>
+            <a:r>
+              <a:rPr lang="en-US" sz="1800" b="1" dirty="0">
+                <a:solidFill>
+                  <a:srgbClr val="FFFFFF"/>
+                </a:solidFill>
+                <a:latin typeface="Calibri" pitchFamily="34" charset="0"/>
+                <a:ea typeface="Calibri" pitchFamily="34" charset="-122"/>
+                <a:cs typeface="Calibri" pitchFamily="34" charset="-120"/>
+              </a:rPr>
+              <a:t>3</a:t>
+            </a:r>
+            <a:endParaRPr lang="en-US" sz="1800" dirty="0"/>
+          </a:p>
+        </p:txBody>
+      </p:sp>
+      <p:sp>
+        <p:nvSpPr>
+          <p:cNvPr id="17" name="Text 15"/>
+          <p:cNvSpPr/>
+          <p:nvPr/>
+        </p:nvSpPr>
+        <p:spPr>
+          <a:xfrm>
+            <a:off x="1508760" y="4050792"/>
+            <a:ext cx="10058400" cy="438912"/>
+          </a:xfrm>
+          <a:prstGeom prst="rect">
+            <a:avLst/>
+          </a:prstGeom>
+          <a:noFill/>
+          <a:ln/>
+        </p:spPr>
+        <p:txBody>
+          <a:bodyPr wrap="square" lIns="0" tIns="0" rIns="0" bIns="0" rtlCol="0" anchor="ctr"/>
+          <a:lstStyle/>
+          <a:p>
+            <a:pPr indent="0" marL="0">
+              <a:buNone/>
+            </a:pPr>
+            <a:r>
+              <a:rPr lang="en-US" sz="1550" b="1" dirty="0">
+                <a:solidFill>
+                  <a:srgbClr val="0B2545"/>
+                </a:solidFill>
+                <a:latin typeface="Calibri" pitchFamily="34" charset="0"/>
+                <a:ea typeface="Calibri" pitchFamily="34" charset="-122"/>
+                <a:cs typeface="Calibri" pitchFamily="34" charset="-120"/>
+              </a:rPr>
+              <a:t>"Which &lt;high-priority&gt; &lt;records&gt; also &lt;2nd condition&gt;?"</a:t>
+            </a:r>
+            <a:endParaRPr lang="en-US" sz="1550" dirty="0"/>
+          </a:p>
+        </p:txBody>
+      </p:sp>
+      <p:sp>
+        <p:nvSpPr>
+          <p:cNvPr id="18" name="Text 16"/>
+          <p:cNvSpPr/>
+          <p:nvPr/>
+        </p:nvSpPr>
+        <p:spPr>
+          <a:xfrm>
+            <a:off x="1508760" y="4443984"/>
+            <a:ext cx="10058400" cy="384048"/>
+          </a:xfrm>
+          <a:prstGeom prst="rect">
+            <a:avLst/>
+          </a:prstGeom>
+          <a:noFill/>
+          <a:ln/>
+        </p:spPr>
+        <p:txBody>
+          <a:bodyPr wrap="square" lIns="0" tIns="0" rIns="0" bIns="0" rtlCol="0" anchor="ctr"/>
+          <a:lstStyle/>
+          <a:p>
+            <a:pPr indent="0" marL="0">
+              <a:buNone/>
+            </a:pPr>
+            <a:r>
+              <a:rPr lang="en-US" sz="1250" dirty="0">
+                <a:solidFill>
+                  <a:srgbClr val="5B6B7F"/>
+                </a:solidFill>
+                <a:latin typeface="Calibri" pitchFamily="34" charset="0"/>
+                <a:ea typeface="Calibri" pitchFamily="34" charset="-122"/>
+                <a:cs typeface="Calibri" pitchFamily="34" charset="-120"/>
+              </a:rPr>
+              <a:t>Centerpiece — a multi-attribute insight with a clear takeaway.</a:t>
+            </a:r>
+            <a:endParaRPr lang="en-US" sz="1250" dirty="0"/>
+          </a:p>
+        </p:txBody>
+      </p:sp>
+      <p:sp>
+        <p:nvSpPr>
+          <p:cNvPr id="19" name="Shape 17"/>
+          <p:cNvSpPr/>
+          <p:nvPr/>
+        </p:nvSpPr>
+        <p:spPr>
+          <a:xfrm>
+            <a:off x="502920" y="5020056"/>
+            <a:ext cx="11201400" cy="932688"/>
+          </a:xfrm>
+          <a:prstGeom prst="roundRect">
+            <a:avLst>
+              <a:gd name="adj" fmla="val 7843"/>
+            </a:avLst>
+          </a:prstGeom>
+          <a:solidFill>
+            <a:srgbClr val="F4F7FA"/>
+          </a:solidFill>
+          <a:ln/>
+          <a:effectLst>
+            <a:outerShdw sx="100000" sy="100000" kx="0" ky="0" algn="bl" rotWithShape="0" blurRad="88900" dist="38100" dir="5400000">
+              <a:srgbClr val="000000">
+                <a:alpha val="12000"/>
+              </a:srgbClr>
+            </a:outerShdw>
+          </a:effectLst>
+        </p:spPr>
+      </p:sp>
+      <p:sp>
+        <p:nvSpPr>
+          <p:cNvPr id="20" name="Shape 18"/>
+          <p:cNvSpPr/>
+          <p:nvPr/>
+        </p:nvSpPr>
+        <p:spPr>
+          <a:xfrm>
+            <a:off x="731520" y="5221224"/>
+            <a:ext cx="566928" cy="566928"/>
+          </a:xfrm>
+          <a:prstGeom prst="ellipse">
+            <a:avLst/>
+          </a:prstGeom>
+          <a:solidFill>
+            <a:srgbClr val="0B2545"/>
+          </a:solidFill>
+          <a:ln/>
+        </p:spPr>
+      </p:sp>
+      <p:sp>
+        <p:nvSpPr>
+          <p:cNvPr id="21" name="Text 19"/>
+          <p:cNvSpPr/>
+          <p:nvPr/>
+        </p:nvSpPr>
+        <p:spPr>
+          <a:xfrm>
+            <a:off x="731520" y="5221224"/>
+            <a:ext cx="566928" cy="566928"/>
+          </a:xfrm>
+          <a:prstGeom prst="rect">
+            <a:avLst/>
+          </a:prstGeom>
+          <a:noFill/>
+          <a:ln/>
+        </p:spPr>
+        <p:txBody>
+          <a:bodyPr wrap="square" lIns="0" tIns="0" rIns="0" bIns="0" rtlCol="0" anchor="ctr"/>
+          <a:lstStyle/>
+          <a:p>
+            <a:pPr algn="ctr" indent="0" marL="0">
+              <a:buNone/>
+            </a:pPr>
+            <a:r>
+              <a:rPr lang="en-US" sz="1800" b="1" dirty="0">
+                <a:solidFill>
+                  <a:srgbClr val="FFFFFF"/>
+                </a:solidFill>
+                <a:latin typeface="Calibri" pitchFamily="34" charset="0"/>
+                <a:ea typeface="Calibri" pitchFamily="34" charset="-122"/>
+                <a:cs typeface="Calibri" pitchFamily="34" charset="-120"/>
+              </a:rPr>
+              <a:t>4</a:t>
+            </a:r>
+            <a:endParaRPr lang="en-US" sz="1800" dirty="0"/>
+          </a:p>
+        </p:txBody>
+      </p:sp>
+      <p:sp>
+        <p:nvSpPr>
+          <p:cNvPr id="22" name="Text 20"/>
+          <p:cNvSpPr/>
+          <p:nvPr/>
+        </p:nvSpPr>
+        <p:spPr>
+          <a:xfrm>
+            <a:off x="1508760" y="5129784"/>
+            <a:ext cx="10058400" cy="438912"/>
+          </a:xfrm>
+          <a:prstGeom prst="rect">
+            <a:avLst/>
+          </a:prstGeom>
+          <a:noFill/>
+          <a:ln/>
+        </p:spPr>
+        <p:txBody>
+          <a:bodyPr wrap="square" lIns="0" tIns="0" rIns="0" bIns="0" rtlCol="0" anchor="ctr"/>
+          <a:lstStyle/>
+          <a:p>
+            <a:pPr indent="0" marL="0">
+              <a:buNone/>
+            </a:pPr>
+            <a:r>
+              <a:rPr lang="en-US" sz="1550" b="1" dirty="0">
+                <a:solidFill>
+                  <a:srgbClr val="0B2545"/>
+                </a:solidFill>
+                <a:latin typeface="Calibri" pitchFamily="34" charset="0"/>
+                <a:ea typeface="Calibri" pitchFamily="34" charset="-122"/>
+                <a:cs typeface="Calibri" pitchFamily="34" charset="-120"/>
+              </a:rPr>
+              <a:t>"Which &lt;records&gt; in &lt;region&gt; intersect &lt;layer&gt;?"</a:t>
+            </a:r>
+            <a:endParaRPr lang="en-US" sz="1550" dirty="0"/>
+          </a:p>
+        </p:txBody>
+      </p:sp>
+      <p:sp>
+        <p:nvSpPr>
+          <p:cNvPr id="23" name="Text 21"/>
+          <p:cNvSpPr/>
+          <p:nvPr/>
+        </p:nvSpPr>
+        <p:spPr>
+          <a:xfrm>
+            <a:off x="1508760" y="5522976"/>
+            <a:ext cx="10058400" cy="384048"/>
+          </a:xfrm>
+          <a:prstGeom prst="rect">
+            <a:avLst/>
+          </a:prstGeom>
+          <a:noFill/>
+          <a:ln/>
+        </p:spPr>
+        <p:txBody>
+          <a:bodyPr wrap="square" lIns="0" tIns="0" rIns="0" bIns="0" rtlCol="0" anchor="ctr"/>
+          <a:lstStyle/>
+          <a:p>
+            <a:pPr indent="0" marL="0">
+              <a:buNone/>
+            </a:pPr>
+            <a:r>
+              <a:rPr lang="en-US" sz="1250" dirty="0">
+                <a:solidFill>
+                  <a:srgbClr val="5B6B7F"/>
+                </a:solidFill>
+                <a:latin typeface="Calibri" pitchFamily="34" charset="0"/>
+                <a:ea typeface="Calibri" pitchFamily="34" charset="-122"/>
+                <a:cs typeface="Calibri" pitchFamily="34" charset="-120"/>
+              </a:rPr>
+              <a:t>Cross-layer reveal — must stay region-scoped (else 413).</a:t>
+            </a:r>
+            <a:endParaRPr lang="en-US" sz="1250" dirty="0"/>
+          </a:p>
+        </p:txBody>
+      </p:sp>
+      <p:sp>
+        <p:nvSpPr>
+          <p:cNvPr id="24" name="Text 22"/>
+          <p:cNvSpPr/>
+          <p:nvPr/>
+        </p:nvSpPr>
+        <p:spPr>
+          <a:xfrm>
+            <a:off x="502920" y="6473952"/>
+            <a:ext cx="7315200" cy="274320"/>
+          </a:xfrm>
+          <a:prstGeom prst="rect">
+            <a:avLst/>
+          </a:prstGeom>
+          <a:noFill/>
+          <a:ln/>
+        </p:spPr>
+        <p:txBody>
+          <a:bodyPr wrap="square" lIns="0" tIns="0" rIns="0" bIns="0" rtlCol="0" anchor="ctr"/>
+          <a:lstStyle/>
+          <a:p>
+            <a:pPr algn="l" indent="0" marL="0">
+              <a:buNone/>
+            </a:pPr>
+            <a:r>
+              <a:rPr lang="en-US" sz="900" dirty="0">
+                <a:solidFill>
+                  <a:srgbClr val="5B6B7F"/>
+                </a:solidFill>
+                <a:latin typeface="Calibri" pitchFamily="34" charset="0"/>
+                <a:ea typeface="Calibri" pitchFamily="34" charset="-122"/>
+                <a:cs typeface="Calibri" pitchFamily="34" charset="-120"/>
+              </a:rPr>
+              <a:t>ArcGIS Maps SDK 5.0 · AI Components Demo</a:t>
+            </a:r>
+            <a:endParaRPr lang="en-US" sz="900" dirty="0"/>
+          </a:p>
+        </p:txBody>
+      </p:sp>
+      <p:sp>
+        <p:nvSpPr>
+          <p:cNvPr id="25" name="Text 23"/>
+          <p:cNvSpPr/>
+          <p:nvPr/>
+        </p:nvSpPr>
+        <p:spPr>
+          <a:xfrm>
+            <a:off x="11277295" y="6473952"/>
+            <a:ext cx="457200" cy="274320"/>
+          </a:xfrm>
+          <a:prstGeom prst="rect">
+            <a:avLst/>
+          </a:prstGeom>
+          <a:noFill/>
+          <a:ln/>
+        </p:spPr>
+        <p:txBody>
+          <a:bodyPr wrap="square" lIns="0" tIns="0" rIns="0" bIns="0" rtlCol="0" anchor="ctr"/>
+          <a:lstStyle/>
+          <a:p>
+            <a:pPr algn="r" indent="0" marL="0">
+              <a:buNone/>
+            </a:pPr>
+            <a:r>
+              <a:rPr lang="en-US" sz="900" dirty="0">
+                <a:solidFill>
+                  <a:srgbClr val="5B6B7F"/>
+                </a:solidFill>
+                <a:latin typeface="Calibri" pitchFamily="34" charset="0"/>
+                <a:ea typeface="Calibri" pitchFamily="34" charset="-122"/>
+                <a:cs typeface="Calibri" pitchFamily="34" charset="-120"/>
+              </a:rPr>
+              <a:t>10</a:t>
+            </a:r>
+            <a:endParaRPr lang="en-US" sz="900" dirty="0"/>
+          </a:p>
+        </p:txBody>
+      </p:sp>
+    </p:spTree>
+  </p:cSld>
+  <p:clrMapOvr>
+    <a:masterClrMapping/>
+  </p:clrMapOvr>
+</p:sld>
+</file>
+
+<file path=ppt/slides/slide11.xml><?xml version="1.0" encoding="utf-8"?>
+<p:sld xmlns:a="http://schemas.openxmlformats.org/drawingml/2006/main" xmlns:r="http://schemas.openxmlformats.org/officeDocument/2006/relationships" xmlns:p="http://schemas.openxmlformats.org/presentationml/2006/main">
+  <p:cSld name="Slide 11">
+    <p:bg>
+      <p:bgPr>
+        <a:solidFill>
           <a:srgbClr val="0B2545"/>
         </a:solidFill>
       </p:bgPr>
@@ -7045,7 +7986,7 @@
         <p:spPr>
           <a:xfrm>
             <a:off x="502920" y="411480"/>
-            <a:ext cx="10972800" cy="640080"/>
+            <a:ext cx="11155680" cy="640080"/>
           </a:xfrm>
           <a:prstGeom prst="rect">
             <a:avLst/>
@@ -7069,7 +8010,7 @@
                 <a:ea typeface="Bookman Old Style" pitchFamily="34" charset="-122"/>
                 <a:cs typeface="Bookman Old Style" pitchFamily="34" charset="-120"/>
               </a:rPr>
-              <a:t>Gotchas that cost us a day</a:t>
+              <a:t>Connecting users: SAML vs built-in</a:t>
             </a:r>
             <a:endParaRPr lang="en-US" sz="3000" dirty="0"/>
           </a:p>
@@ -7077,18 +8018,57 @@
       </p:sp>
       <p:sp>
         <p:nvSpPr>
-          <p:cNvPr id="3" name="Shape 1"/>
-          <p:cNvSpPr/>
-          <p:nvPr/>
-        </p:nvSpPr>
-        <p:spPr>
-          <a:xfrm>
-            <a:off x="502920" y="1325880"/>
-            <a:ext cx="3657600" cy="2148840"/>
+          <p:cNvPr id="3" name="Text 1"/>
+          <p:cNvSpPr/>
+          <p:nvPr/>
+        </p:nvSpPr>
+        <p:spPr>
+          <a:xfrm>
+            <a:off x="502920" y="1078992"/>
+            <a:ext cx="10972800" cy="548640"/>
+          </a:xfrm>
+          <a:prstGeom prst="rect">
+            <a:avLst/>
+          </a:prstGeom>
+          <a:noFill/>
+          <a:ln/>
+        </p:spPr>
+        <p:txBody>
+          <a:bodyPr wrap="square" lIns="0" tIns="0" rIns="0" bIns="0" rtlCol="0" anchor="ctr"/>
+          <a:lstStyle/>
+          <a:p>
+            <a:pPr indent="0" marL="0">
+              <a:buNone/>
+            </a:pPr>
+            <a:r>
+              <a:rPr lang="en-US" sz="1400" dirty="0">
+                <a:solidFill>
+                  <a:srgbClr val="5B6B7F"/>
+                </a:solidFill>
+                <a:latin typeface="Calibri" pitchFamily="34" charset="0"/>
+                <a:ea typeface="Calibri" pitchFamily="34" charset="-122"/>
+                <a:cs typeface="Calibri" pitchFamily="34" charset="-120"/>
+              </a:rPr>
+              <a:t>Both use the same OAuth 2.0 user-auth flow and the same app code — the only lever is the portal URL.</a:t>
+            </a:r>
+            <a:endParaRPr lang="en-US" sz="1400" dirty="0"/>
+          </a:p>
+        </p:txBody>
+      </p:sp>
+      <p:sp>
+        <p:nvSpPr>
+          <p:cNvPr id="4" name="Shape 2"/>
+          <p:cNvSpPr/>
+          <p:nvPr/>
+        </p:nvSpPr>
+        <p:spPr>
+          <a:xfrm>
+            <a:off x="502920" y="1783080"/>
+            <a:ext cx="5486400" cy="3108960"/>
           </a:xfrm>
           <a:prstGeom prst="roundRect">
             <a:avLst>
-              <a:gd name="adj" fmla="val 3404"/>
+              <a:gd name="adj" fmla="val 2941"/>
             </a:avLst>
           </a:prstGeom>
           <a:solidFill>
@@ -7106,27 +8086,27 @@
       </p:sp>
       <p:sp>
         <p:nvSpPr>
-          <p:cNvPr id="4" name="Shape 2"/>
-          <p:cNvSpPr/>
-          <p:nvPr/>
-        </p:nvSpPr>
-        <p:spPr>
-          <a:xfrm>
-            <a:off x="758952" y="1581912"/>
-            <a:ext cx="713232" cy="713232"/>
+          <p:cNvPr id="5" name="Shape 3"/>
+          <p:cNvSpPr/>
+          <p:nvPr/>
+        </p:nvSpPr>
+        <p:spPr>
+          <a:xfrm>
+            <a:off x="868680" y="2057400"/>
+            <a:ext cx="822960" cy="822960"/>
           </a:xfrm>
           <a:prstGeom prst="ellipse">
             <a:avLst/>
           </a:prstGeom>
           <a:solidFill>
-            <a:srgbClr val="E8A33D"/>
+            <a:srgbClr val="1C7293"/>
           </a:solidFill>
           <a:ln/>
         </p:spPr>
       </p:sp>
       <p:pic>
         <p:nvPicPr>
-          <p:cNvPr id="5" name="Image 0" descr="preencoded.png">    </p:cNvPr>
+          <p:cNvPr id="6" name="Image 0" descr="preencoded.png">    </p:cNvPr>
           <p:cNvPicPr>
             <a:picLocks noChangeAspect="1"/>
           </p:cNvPicPr>
@@ -7140,8 +8120,8 @@
         </p:blipFill>
         <p:spPr>
           <a:xfrm>
-            <a:off x="944392" y="1767352"/>
-            <a:ext cx="342351" cy="342351"/>
+            <a:off x="1082650" y="2271370"/>
+            <a:ext cx="395021" cy="395021"/>
           </a:xfrm>
           <a:prstGeom prst="rect">
             <a:avLst/>
@@ -7150,14 +8130,14 @@
       </p:pic>
       <p:sp>
         <p:nvSpPr>
-          <p:cNvPr id="6" name="Text 3"/>
-          <p:cNvSpPr/>
-          <p:nvPr/>
-        </p:nvSpPr>
-        <p:spPr>
-          <a:xfrm>
-            <a:off x="1600200" y="1600200"/>
-            <a:ext cx="2377440" cy="685800"/>
+          <p:cNvPr id="7" name="Text 4"/>
+          <p:cNvSpPr/>
+          <p:nvPr/>
+        </p:nvSpPr>
+        <p:spPr>
+          <a:xfrm>
+            <a:off x="1783080" y="2103120"/>
+            <a:ext cx="4023360" cy="731520"/>
           </a:xfrm>
           <a:prstGeom prst="rect">
             <a:avLst/>
@@ -7170,88 +8150,166 @@
           <a:lstStyle/>
           <a:p>
             <a:pPr indent="0" marL="0">
+              <a:buNone/>
+            </a:pPr>
+            <a:r>
+              <a:rPr lang="en-US" sz="1600" b="1" dirty="0">
+                <a:solidFill>
+                  <a:srgbClr val="0B2545"/>
+                </a:solidFill>
+                <a:latin typeface="Calibri" pitchFamily="34" charset="0"/>
+                <a:ea typeface="Calibri" pitchFamily="34" charset="-122"/>
+                <a:cs typeface="Calibri" pitchFamily="34" charset="-120"/>
+              </a:rPr>
+              <a:t>Built-in account</a:t>
+            </a:r>
+            <a:endParaRPr lang="en-US" sz="1600" dirty="0"/>
+          </a:p>
+        </p:txBody>
+      </p:sp>
+      <p:sp>
+        <p:nvSpPr>
+          <p:cNvPr id="8" name="Text 5"/>
+          <p:cNvSpPr/>
+          <p:nvPr/>
+        </p:nvSpPr>
+        <p:spPr>
+          <a:xfrm>
+            <a:off x="868680" y="2971800"/>
+            <a:ext cx="4800600" cy="1828800"/>
+          </a:xfrm>
+          <a:prstGeom prst="rect">
+            <a:avLst/>
+          </a:prstGeom>
+          <a:noFill/>
+          <a:ln/>
+        </p:spPr>
+        <p:txBody>
+          <a:bodyPr wrap="square" lIns="0" tIns="0" rIns="0" bIns="0" rtlCol="0" anchor="ctr"/>
+          <a:lstStyle/>
+          <a:p>
+            <a:pPr marL="342900" indent="-342900">
               <a:lnSpc>
-                <a:spcPts val="1600"/>
+                <a:spcPts val="1800"/>
               </a:lnSpc>
-              <a:buNone/>
-            </a:pPr>
-            <a:r>
-              <a:rPr lang="en-US" sz="1450" b="1" dirty="0">
-                <a:solidFill>
-                  <a:srgbClr val="0B2545"/>
-                </a:solidFill>
-                <a:latin typeface="Calibri" pitchFamily="34" charset="0"/>
-                <a:ea typeface="Calibri" pitchFamily="34" charset="-122"/>
-                <a:cs typeface="Calibri" pitchFamily="34" charset="-120"/>
-              </a:rPr>
-              <a:t>Elements don't auto-register</a:t>
-            </a:r>
-            <a:endParaRPr lang="en-US" sz="1450" dirty="0"/>
-          </a:p>
-        </p:txBody>
-      </p:sp>
-      <p:sp>
-        <p:nvSpPr>
-          <p:cNvPr id="7" name="Text 4"/>
-          <p:cNvSpPr/>
-          <p:nvPr/>
-        </p:nvSpPr>
-        <p:spPr>
-          <a:xfrm>
-            <a:off x="758952" y="2350008"/>
-            <a:ext cx="3145536" cy="1005840"/>
-          </a:xfrm>
-          <a:prstGeom prst="rect">
-            <a:avLst/>
-          </a:prstGeom>
-          <a:noFill/>
-          <a:ln/>
-        </p:spPr>
-        <p:txBody>
-          <a:bodyPr wrap="square" lIns="0" tIns="0" rIns="0" bIns="0" rtlCol="0" anchor="ctr"/>
-          <a:lstStyle/>
-          <a:p>
-            <a:pPr indent="0" marL="0">
+              <a:spcAft>
+                <a:spcPts val="800"/>
+              </a:spcAft>
+              <a:buSzPct val="100000"/>
+              <a:buChar char="•"/>
+            </a:pPr>
+            <a:r>
+              <a:rPr lang="en-US" sz="1250" dirty="0">
+                <a:solidFill>
+                  <a:srgbClr val="1E293B"/>
+                </a:solidFill>
+                <a:latin typeface="Calibri" pitchFamily="34" charset="0"/>
+                <a:ea typeface="Calibri" pitchFamily="34" charset="-122"/>
+                <a:cs typeface="Calibri" pitchFamily="34" charset="-120"/>
+              </a:rPr>
+              <a:t>Credentials live in ArcGIS Online</a:t>
+            </a:r>
+            <a:endParaRPr lang="en-US" sz="1250" dirty="0"/>
+          </a:p>
+          <a:p>
+            <a:pPr marL="342900" indent="-342900">
               <a:lnSpc>
-                <a:spcPts val="1450"/>
+                <a:spcPts val="1800"/>
               </a:lnSpc>
-              <a:buNone/>
-            </a:pPr>
-            <a:r>
-              <a:rPr lang="en-US" sz="1150" dirty="0">
-                <a:solidFill>
-                  <a:srgbClr val="5B6B7F"/>
-                </a:solidFill>
-                <a:latin typeface="Calibri" pitchFamily="34" charset="0"/>
-                <a:ea typeface="Calibri" pitchFamily="34" charset="-122"/>
-                <a:cs typeface="Calibri" pitchFamily="34" charset="-120"/>
-              </a:rPr>
-              <a:t>SDK 5.x is Lumina-based. Bare imports do nothing — call defineCustomElements() or you get "Custom element not found."</a:t>
-            </a:r>
-            <a:endParaRPr lang="en-US" sz="1150" dirty="0"/>
-          </a:p>
-        </p:txBody>
-      </p:sp>
-      <p:sp>
-        <p:nvSpPr>
-          <p:cNvPr id="8" name="Shape 5"/>
-          <p:cNvSpPr/>
-          <p:nvPr/>
-        </p:nvSpPr>
-        <p:spPr>
-          <a:xfrm>
-            <a:off x="4398264" y="1325880"/>
-            <a:ext cx="3657600" cy="2148840"/>
+              <a:spcAft>
+                <a:spcPts val="800"/>
+              </a:spcAft>
+              <a:buSzPct val="100000"/>
+              <a:buChar char="•"/>
+            </a:pPr>
+            <a:r>
+              <a:rPr lang="en-US" sz="1250" dirty="0">
+                <a:solidFill>
+                  <a:srgbClr val="1E293B"/>
+                </a:solidFill>
+                <a:latin typeface="Calibri" pitchFamily="34" charset="0"/>
+                <a:ea typeface="Calibri" pitchFamily="34" charset="-122"/>
+                <a:cs typeface="Calibri" pitchFamily="34" charset="-120"/>
+              </a:rPr>
+              <a:t>Signs in directly on the ArcGIS sign-in page</a:t>
+            </a:r>
+            <a:endParaRPr lang="en-US" sz="1250" dirty="0"/>
+          </a:p>
+          <a:p>
+            <a:pPr marL="342900" indent="-342900">
+              <a:lnSpc>
+                <a:spcPts val="1800"/>
+              </a:lnSpc>
+              <a:spcAft>
+                <a:spcPts val="800"/>
+              </a:spcAft>
+              <a:buSzPct val="100000"/>
+              <a:buChar char="•"/>
+            </a:pPr>
+            <a:r>
+              <a:rPr lang="en-US" sz="1250" dirty="0">
+                <a:solidFill>
+                  <a:srgbClr val="1E293B"/>
+                </a:solidFill>
+                <a:latin typeface="Calibri" pitchFamily="34" charset="0"/>
+                <a:ea typeface="Calibri" pitchFamily="34" charset="-122"/>
+                <a:cs typeface="Calibri" pitchFamily="34" charset="-120"/>
+              </a:rPr>
+              <a:t>Org password policy applies</a:t>
+            </a:r>
+            <a:endParaRPr lang="en-US" sz="1250" dirty="0"/>
+          </a:p>
+          <a:p>
+            <a:pPr marL="342900" indent="-342900">
+              <a:lnSpc>
+                <a:spcPts val="1800"/>
+              </a:lnSpc>
+              <a:spcAft>
+                <a:spcPts val="800"/>
+              </a:spcAft>
+              <a:buSzPct val="100000"/>
+              <a:buChar char="•"/>
+            </a:pPr>
+            <a:r>
+              <a:rPr lang="en-US" sz="1250" dirty="0">
+                <a:solidFill>
+                  <a:srgbClr val="1E293B"/>
+                </a:solidFill>
+                <a:latin typeface="Calibri" pitchFamily="34" charset="0"/>
+                <a:ea typeface="Calibri" pitchFamily="34" charset="-122"/>
+                <a:cs typeface="Calibri" pitchFamily="34" charset="-120"/>
+              </a:rPr>
+              <a:t>Username, e.g. jsmith</a:t>
+            </a:r>
+            <a:endParaRPr lang="en-US" sz="1250" dirty="0"/>
+          </a:p>
+        </p:txBody>
+      </p:sp>
+      <p:sp>
+        <p:nvSpPr>
+          <p:cNvPr id="9" name="Shape 6"/>
+          <p:cNvSpPr/>
+          <p:nvPr/>
+        </p:nvSpPr>
+        <p:spPr>
+          <a:xfrm>
+            <a:off x="6217920" y="1783080"/>
+            <a:ext cx="5486400" cy="3108960"/>
           </a:xfrm>
           <a:prstGeom prst="roundRect">
             <a:avLst>
-              <a:gd name="adj" fmla="val 3404"/>
+              <a:gd name="adj" fmla="val 2941"/>
             </a:avLst>
           </a:prstGeom>
           <a:solidFill>
             <a:srgbClr val="F4F7FA"/>
           </a:solidFill>
-          <a:ln/>
+          <a:ln w="12700">
+            <a:solidFill>
+              <a:srgbClr val="1C7293"/>
+            </a:solidFill>
+            <a:prstDash val="solid"/>
+          </a:ln>
           <a:effectLst>
             <a:outerShdw sx="100000" sy="100000" kx="0" ky="0" algn="bl" rotWithShape="0" blurRad="88900" dist="38100" dir="5400000">
               <a:srgbClr val="000000">
@@ -7263,14 +8321,14 @@
       </p:sp>
       <p:sp>
         <p:nvSpPr>
-          <p:cNvPr id="9" name="Shape 6"/>
-          <p:cNvSpPr/>
-          <p:nvPr/>
-        </p:nvSpPr>
-        <p:spPr>
-          <a:xfrm>
-            <a:off x="4654296" y="1581912"/>
-            <a:ext cx="713232" cy="713232"/>
+          <p:cNvPr id="10" name="Shape 7"/>
+          <p:cNvSpPr/>
+          <p:nvPr/>
+        </p:nvSpPr>
+        <p:spPr>
+          <a:xfrm>
+            <a:off x="6583680" y="2057400"/>
+            <a:ext cx="822960" cy="822960"/>
           </a:xfrm>
           <a:prstGeom prst="ellipse">
             <a:avLst/>
@@ -7283,7 +8341,7 @@
       </p:sp>
       <p:pic>
         <p:nvPicPr>
-          <p:cNvPr id="10" name="Image 1" descr="preencoded.png">    </p:cNvPr>
+          <p:cNvPr id="11" name="Image 1" descr="preencoded.png">    </p:cNvPr>
           <p:cNvPicPr>
             <a:picLocks noChangeAspect="1"/>
           </p:cNvPicPr>
@@ -7297,8 +8355,8 @@
         </p:blipFill>
         <p:spPr>
           <a:xfrm>
-            <a:off x="4839736" y="1767352"/>
-            <a:ext cx="342351" cy="342351"/>
+            <a:off x="6797650" y="2271370"/>
+            <a:ext cx="395021" cy="395021"/>
           </a:xfrm>
           <a:prstGeom prst="rect">
             <a:avLst/>
@@ -7307,14 +8365,193 @@
       </p:pic>
       <p:sp>
         <p:nvSpPr>
-          <p:cNvPr id="11" name="Text 7"/>
-          <p:cNvSpPr/>
-          <p:nvPr/>
-        </p:nvSpPr>
-        <p:spPr>
-          <a:xfrm>
-            <a:off x="5495544" y="1600200"/>
-            <a:ext cx="2377440" cy="685800"/>
+          <p:cNvPr id="12" name="Text 8"/>
+          <p:cNvSpPr/>
+          <p:nvPr/>
+        </p:nvSpPr>
+        <p:spPr>
+          <a:xfrm>
+            <a:off x="7498080" y="2103120"/>
+            <a:ext cx="4069080" cy="731520"/>
+          </a:xfrm>
+          <a:prstGeom prst="rect">
+            <a:avLst/>
+          </a:prstGeom>
+          <a:noFill/>
+          <a:ln/>
+        </p:spPr>
+        <p:txBody>
+          <a:bodyPr wrap="square" lIns="0" tIns="0" rIns="0" bIns="0" rtlCol="0" anchor="ctr"/>
+          <a:lstStyle/>
+          <a:p>
+            <a:pPr indent="0" marL="0">
+              <a:buNone/>
+            </a:pPr>
+            <a:r>
+              <a:rPr lang="en-US" sz="1600" b="1" dirty="0">
+                <a:solidFill>
+                  <a:srgbClr val="0B2545"/>
+                </a:solidFill>
+                <a:latin typeface="Calibri" pitchFamily="34" charset="0"/>
+                <a:ea typeface="Calibri" pitchFamily="34" charset="-122"/>
+                <a:cs typeface="Calibri" pitchFamily="34" charset="-120"/>
+              </a:rPr>
+              <a:t>SAML / org-specific login</a:t>
+            </a:r>
+            <a:endParaRPr lang="en-US" sz="1600" dirty="0"/>
+          </a:p>
+        </p:txBody>
+      </p:sp>
+      <p:sp>
+        <p:nvSpPr>
+          <p:cNvPr id="13" name="Text 9"/>
+          <p:cNvSpPr/>
+          <p:nvPr/>
+        </p:nvSpPr>
+        <p:spPr>
+          <a:xfrm>
+            <a:off x="6583680" y="2971800"/>
+            <a:ext cx="4800600" cy="1828800"/>
+          </a:xfrm>
+          <a:prstGeom prst="rect">
+            <a:avLst/>
+          </a:prstGeom>
+          <a:noFill/>
+          <a:ln/>
+        </p:spPr>
+        <p:txBody>
+          <a:bodyPr wrap="square" lIns="0" tIns="0" rIns="0" bIns="0" rtlCol="0" anchor="ctr"/>
+          <a:lstStyle/>
+          <a:p>
+            <a:pPr marL="342900" indent="-342900">
+              <a:lnSpc>
+                <a:spcPts val="1800"/>
+              </a:lnSpc>
+              <a:spcAft>
+                <a:spcPts val="800"/>
+              </a:spcAft>
+              <a:buSzPct val="100000"/>
+              <a:buChar char="•"/>
+            </a:pPr>
+            <a:r>
+              <a:rPr lang="en-US" sz="1250" dirty="0">
+                <a:solidFill>
+                  <a:srgbClr val="1E293B"/>
+                </a:solidFill>
+                <a:latin typeface="Calibri" pitchFamily="34" charset="0"/>
+                <a:ea typeface="Calibri" pitchFamily="34" charset="-122"/>
+                <a:cs typeface="Calibri" pitchFamily="34" charset="-120"/>
+              </a:rPr>
+              <a:t>Credentials live in your identity provider (IdP)</a:t>
+            </a:r>
+            <a:endParaRPr lang="en-US" sz="1250" dirty="0"/>
+          </a:p>
+          <a:p>
+            <a:pPr marL="342900" indent="-342900">
+              <a:lnSpc>
+                <a:spcPts val="1800"/>
+              </a:lnSpc>
+              <a:spcAft>
+                <a:spcPts val="800"/>
+              </a:spcAft>
+              <a:buSzPct val="100000"/>
+              <a:buChar char="•"/>
+            </a:pPr>
+            <a:r>
+              <a:rPr lang="en-US" sz="1250" dirty="0">
+                <a:solidFill>
+                  <a:srgbClr val="1E293B"/>
+                </a:solidFill>
+                <a:latin typeface="Calibri" pitchFamily="34" charset="0"/>
+                <a:ea typeface="Calibri" pitchFamily="34" charset="-122"/>
+                <a:cs typeface="Calibri" pitchFamily="34" charset="-120"/>
+              </a:rPr>
+              <a:t>Redirected to your IdP to sign in</a:t>
+            </a:r>
+            <a:endParaRPr lang="en-US" sz="1250" dirty="0"/>
+          </a:p>
+          <a:p>
+            <a:pPr marL="342900" indent="-342900">
+              <a:lnSpc>
+                <a:spcPts val="1800"/>
+              </a:lnSpc>
+              <a:spcAft>
+                <a:spcPts val="800"/>
+              </a:spcAft>
+              <a:buSzPct val="100000"/>
+              <a:buChar char="•"/>
+            </a:pPr>
+            <a:r>
+              <a:rPr lang="en-US" sz="1250" dirty="0">
+                <a:solidFill>
+                  <a:srgbClr val="1E293B"/>
+                </a:solidFill>
+                <a:latin typeface="Calibri" pitchFamily="34" charset="0"/>
+                <a:ea typeface="Calibri" pitchFamily="34" charset="-122"/>
+                <a:cs typeface="Calibri" pitchFamily="34" charset="-120"/>
+              </a:rPr>
+              <a:t>Formerly called "enterprise logins"</a:t>
+            </a:r>
+            <a:endParaRPr lang="en-US" sz="1250" dirty="0"/>
+          </a:p>
+          <a:p>
+            <a:pPr marL="342900" indent="-342900">
+              <a:lnSpc>
+                <a:spcPts val="1800"/>
+              </a:lnSpc>
+              <a:spcAft>
+                <a:spcPts val="800"/>
+              </a:spcAft>
+              <a:buSzPct val="100000"/>
+              <a:buChar char="•"/>
+            </a:pPr>
+            <a:r>
+              <a:rPr lang="en-US" sz="1250" dirty="0">
+                <a:solidFill>
+                  <a:srgbClr val="1E293B"/>
+                </a:solidFill>
+                <a:latin typeface="Calibri" pitchFamily="34" charset="0"/>
+                <a:ea typeface="Calibri" pitchFamily="34" charset="-122"/>
+                <a:cs typeface="Calibri" pitchFamily="34" charset="-120"/>
+              </a:rPr>
+              <a:t>Username carries the org-key suffix: jsmith@ORG</a:t>
+            </a:r>
+            <a:endParaRPr lang="en-US" sz="1250" dirty="0"/>
+          </a:p>
+        </p:txBody>
+      </p:sp>
+      <p:sp>
+        <p:nvSpPr>
+          <p:cNvPr id="14" name="Shape 10"/>
+          <p:cNvSpPr/>
+          <p:nvPr/>
+        </p:nvSpPr>
+        <p:spPr>
+          <a:xfrm>
+            <a:off x="502920" y="5120640"/>
+            <a:ext cx="11201400" cy="960120"/>
+          </a:xfrm>
+          <a:prstGeom prst="roundRect">
+            <a:avLst>
+              <a:gd name="adj" fmla="val 7619"/>
+            </a:avLst>
+          </a:prstGeom>
+          <a:solidFill>
+            <a:srgbClr val="0B2545"/>
+          </a:solidFill>
+          <a:ln/>
+        </p:spPr>
+      </p:sp>
+      <p:sp>
+        <p:nvSpPr>
+          <p:cNvPr id="15" name="Text 11"/>
+          <p:cNvSpPr/>
+          <p:nvPr/>
+        </p:nvSpPr>
+        <p:spPr>
+          <a:xfrm>
+            <a:off x="868680" y="5120640"/>
+            <a:ext cx="10515600" cy="960120"/>
           </a:xfrm>
           <a:prstGeom prst="rect">
             <a:avLst/>
@@ -7328,698 +8565,45 @@
           <a:p>
             <a:pPr indent="0" marL="0">
               <a:lnSpc>
-                <a:spcPts val="1600"/>
+                <a:spcPts val="1700"/>
               </a:lnSpc>
               <a:buNone/>
             </a:pPr>
             <a:r>
-              <a:rPr lang="en-US" sz="1450" b="1" dirty="0">
-                <a:solidFill>
-                  <a:srgbClr val="0B2545"/>
-                </a:solidFill>
-                <a:latin typeface="Calibri" pitchFamily="34" charset="0"/>
-                <a:ea typeface="Calibri" pitchFamily="34" charset="-122"/>
-                <a:cs typeface="Calibri" pitchFamily="34" charset="-120"/>
-              </a:rPr>
-              <a:t>No ai-components-react</a:t>
-            </a:r>
-            <a:endParaRPr lang="en-US" sz="1450" dirty="0"/>
-          </a:p>
-        </p:txBody>
-      </p:sp>
-      <p:sp>
-        <p:nvSpPr>
-          <p:cNvPr id="12" name="Text 8"/>
-          <p:cNvSpPr/>
-          <p:nvPr/>
-        </p:nvSpPr>
-        <p:spPr>
-          <a:xfrm>
-            <a:off x="4654296" y="2350008"/>
-            <a:ext cx="3145536" cy="1005840"/>
-          </a:xfrm>
-          <a:prstGeom prst="rect">
-            <a:avLst/>
-          </a:prstGeom>
-          <a:noFill/>
-          <a:ln/>
-        </p:spPr>
-        <p:txBody>
-          <a:bodyPr wrap="square" lIns="0" tIns="0" rIns="0" bIns="0" rtlCol="0" anchor="ctr"/>
-          <a:lstStyle/>
-          <a:p>
+              <a:rPr lang="en-US" sz="1300" b="1" dirty="0">
+                <a:solidFill>
+                  <a:srgbClr val="E8A33D"/>
+                </a:solidFill>
+                <a:latin typeface="Calibri" pitchFamily="34" charset="0"/>
+                <a:ea typeface="Calibri" pitchFamily="34" charset="-122"/>
+                <a:cs typeface="Calibri" pitchFamily="34" charset="-120"/>
+              </a:rPr>
+              <a:t>The only lever is VITE_PORTAL_URL:  </a:t>
+            </a:r>
             <a:pPr indent="0" marL="0">
               <a:lnSpc>
-                <a:spcPts val="1450"/>
+                <a:spcPts val="1700"/>
               </a:lnSpc>
               <a:buNone/>
             </a:pPr>
             <a:r>
-              <a:rPr lang="en-US" sz="1150" dirty="0">
-                <a:solidFill>
-                  <a:srgbClr val="5B6B7F"/>
-                </a:solidFill>
-                <a:latin typeface="Calibri" pitchFamily="34" charset="0"/>
-                <a:ea typeface="Calibri" pitchFamily="34" charset="-122"/>
-                <a:cs typeface="Calibri" pitchFamily="34" charset="-120"/>
-              </a:rPr>
-              <a:t>AI components ship as raw web components only. Declare the tags in vite-env.d.ts; set props imperatively via refs.</a:t>
-            </a:r>
-            <a:endParaRPr lang="en-US" sz="1150" dirty="0"/>
-          </a:p>
-        </p:txBody>
-      </p:sp>
-      <p:sp>
-        <p:nvSpPr>
-          <p:cNvPr id="13" name="Shape 9"/>
-          <p:cNvSpPr/>
-          <p:nvPr/>
-        </p:nvSpPr>
-        <p:spPr>
-          <a:xfrm>
-            <a:off x="8293608" y="1325880"/>
-            <a:ext cx="3657600" cy="2148840"/>
-          </a:xfrm>
-          <a:prstGeom prst="roundRect">
-            <a:avLst>
-              <a:gd name="adj" fmla="val 3404"/>
-            </a:avLst>
-          </a:prstGeom>
-          <a:solidFill>
-            <a:srgbClr val="F4F7FA"/>
-          </a:solidFill>
-          <a:ln/>
-          <a:effectLst>
-            <a:outerShdw sx="100000" sy="100000" kx="0" ky="0" algn="bl" rotWithShape="0" blurRad="88900" dist="38100" dir="5400000">
-              <a:srgbClr val="000000">
-                <a:alpha val="12000"/>
-              </a:srgbClr>
-            </a:outerShdw>
-          </a:effectLst>
-        </p:spPr>
-      </p:sp>
-      <p:sp>
-        <p:nvSpPr>
-          <p:cNvPr id="14" name="Shape 10"/>
-          <p:cNvSpPr/>
-          <p:nvPr/>
-        </p:nvSpPr>
-        <p:spPr>
-          <a:xfrm>
-            <a:off x="8549640" y="1581912"/>
-            <a:ext cx="713232" cy="713232"/>
-          </a:xfrm>
-          <a:prstGeom prst="ellipse">
-            <a:avLst/>
-          </a:prstGeom>
-          <a:solidFill>
-            <a:srgbClr val="E8A33D"/>
-          </a:solidFill>
-          <a:ln/>
-        </p:spPr>
-      </p:sp>
-      <p:pic>
-        <p:nvPicPr>
-          <p:cNvPr id="15" name="Image 2" descr="preencoded.png">    </p:cNvPr>
-          <p:cNvPicPr>
-            <a:picLocks noChangeAspect="1"/>
-          </p:cNvPicPr>
-          <p:nvPr/>
-        </p:nvPicPr>
-        <p:blipFill>
-          <a:blip r:embed="rId3"/>
-          <a:stretch>
-            <a:fillRect/>
-          </a:stretch>
-        </p:blipFill>
-        <p:spPr>
-          <a:xfrm>
-            <a:off x="8735080" y="1767352"/>
-            <a:ext cx="342351" cy="342351"/>
-          </a:xfrm>
-          <a:prstGeom prst="rect">
-            <a:avLst/>
-          </a:prstGeom>
-        </p:spPr>
-      </p:pic>
-      <p:sp>
-        <p:nvSpPr>
-          <p:cNvPr id="16" name="Text 11"/>
-          <p:cNvSpPr/>
-          <p:nvPr/>
-        </p:nvSpPr>
-        <p:spPr>
-          <a:xfrm>
-            <a:off x="9390888" y="1600200"/>
-            <a:ext cx="2377440" cy="685800"/>
-          </a:xfrm>
-          <a:prstGeom prst="rect">
-            <a:avLst/>
-          </a:prstGeom>
-          <a:noFill/>
-          <a:ln/>
-        </p:spPr>
-        <p:txBody>
-          <a:bodyPr wrap="square" lIns="0" tIns="0" rIns="0" bIns="0" rtlCol="0" anchor="ctr"/>
-          <a:lstStyle/>
-          <a:p>
-            <a:pPr indent="0" marL="0">
-              <a:lnSpc>
-                <a:spcPts val="1600"/>
-              </a:lnSpc>
-              <a:buNone/>
-            </a:pPr>
-            <a:r>
-              <a:rPr lang="en-US" sz="1450" b="1" dirty="0">
-                <a:solidFill>
-                  <a:srgbClr val="0B2545"/>
-                </a:solidFill>
-                <a:latin typeface="Calibri" pitchFamily="34" charset="0"/>
-                <a:ea typeface="Calibri" pitchFamily="34" charset="-122"/>
-                <a:cs typeface="Calibri" pitchFamily="34" charset="-120"/>
-              </a:rPr>
-              <a:t>Embeddings 504 ≠ CORS</a:t>
-            </a:r>
-            <a:endParaRPr lang="en-US" sz="1450" dirty="0"/>
-          </a:p>
-        </p:txBody>
-      </p:sp>
-      <p:sp>
-        <p:nvSpPr>
-          <p:cNvPr id="17" name="Text 12"/>
-          <p:cNvSpPr/>
-          <p:nvPr/>
-        </p:nvSpPr>
-        <p:spPr>
-          <a:xfrm>
-            <a:off x="8549640" y="2350008"/>
-            <a:ext cx="3145536" cy="1005840"/>
-          </a:xfrm>
-          <a:prstGeom prst="rect">
-            <a:avLst/>
-          </a:prstGeom>
-          <a:noFill/>
-          <a:ln/>
-        </p:spPr>
-        <p:txBody>
-          <a:bodyPr wrap="square" lIns="0" tIns="0" rIns="0" bIns="0" rtlCol="0" anchor="ctr"/>
-          <a:lstStyle/>
-          <a:p>
-            <a:pPr indent="0" marL="0">
-              <a:lnSpc>
-                <a:spcPts val="1450"/>
-              </a:lnSpc>
-              <a:buNone/>
-            </a:pPr>
-            <a:r>
-              <a:rPr lang="en-US" sz="1150" dirty="0">
-                <a:solidFill>
-                  <a:srgbClr val="5B6B7F"/>
-                </a:solidFill>
-                <a:latin typeface="Calibri" pitchFamily="34" charset="0"/>
-                <a:ea typeface="Calibri" pitchFamily="34" charset="-122"/>
-                <a:cs typeface="Calibri" pitchFamily="34" charset="-120"/>
-              </a:rPr>
-              <a:t>Generic error looks like CORS but is a 504 timeout. Wide-schema reference layers trigger it; narrow ones succeed.</a:t>
-            </a:r>
-            <a:endParaRPr lang="en-US" sz="1150" dirty="0"/>
-          </a:p>
-        </p:txBody>
-      </p:sp>
-      <p:sp>
-        <p:nvSpPr>
-          <p:cNvPr id="18" name="Shape 13"/>
-          <p:cNvSpPr/>
-          <p:nvPr/>
-        </p:nvSpPr>
-        <p:spPr>
-          <a:xfrm>
-            <a:off x="502920" y="3749040"/>
-            <a:ext cx="3657600" cy="2148840"/>
-          </a:xfrm>
-          <a:prstGeom prst="roundRect">
-            <a:avLst>
-              <a:gd name="adj" fmla="val 3404"/>
-            </a:avLst>
-          </a:prstGeom>
-          <a:solidFill>
-            <a:srgbClr val="F4F7FA"/>
-          </a:solidFill>
-          <a:ln/>
-          <a:effectLst>
-            <a:outerShdw sx="100000" sy="100000" kx="0" ky="0" algn="bl" rotWithShape="0" blurRad="88900" dist="38100" dir="5400000">
-              <a:srgbClr val="000000">
-                <a:alpha val="12000"/>
-              </a:srgbClr>
-            </a:outerShdw>
-          </a:effectLst>
-        </p:spPr>
-      </p:sp>
-      <p:sp>
-        <p:nvSpPr>
-          <p:cNvPr id="19" name="Shape 14"/>
-          <p:cNvSpPr/>
-          <p:nvPr/>
-        </p:nvSpPr>
-        <p:spPr>
-          <a:xfrm>
-            <a:off x="758952" y="4005072"/>
-            <a:ext cx="713232" cy="713232"/>
-          </a:xfrm>
-          <a:prstGeom prst="ellipse">
-            <a:avLst/>
-          </a:prstGeom>
-          <a:solidFill>
-            <a:srgbClr val="E8A33D"/>
-          </a:solidFill>
-          <a:ln/>
-        </p:spPr>
-      </p:sp>
-      <p:pic>
-        <p:nvPicPr>
-          <p:cNvPr id="20" name="Image 3" descr="preencoded.png">    </p:cNvPr>
-          <p:cNvPicPr>
-            <a:picLocks noChangeAspect="1"/>
-          </p:cNvPicPr>
-          <p:nvPr/>
-        </p:nvPicPr>
-        <p:blipFill>
-          <a:blip r:embed="rId4"/>
-          <a:stretch>
-            <a:fillRect/>
-          </a:stretch>
-        </p:blipFill>
-        <p:spPr>
-          <a:xfrm>
-            <a:off x="944392" y="4190512"/>
-            <a:ext cx="342351" cy="342351"/>
-          </a:xfrm>
-          <a:prstGeom prst="rect">
-            <a:avLst/>
-          </a:prstGeom>
-        </p:spPr>
-      </p:pic>
-      <p:sp>
-        <p:nvSpPr>
-          <p:cNvPr id="21" name="Text 15"/>
-          <p:cNvSpPr/>
-          <p:nvPr/>
-        </p:nvSpPr>
-        <p:spPr>
-          <a:xfrm>
-            <a:off x="1600200" y="4023360"/>
-            <a:ext cx="2377440" cy="685800"/>
-          </a:xfrm>
-          <a:prstGeom prst="rect">
-            <a:avLst/>
-          </a:prstGeom>
-          <a:noFill/>
-          <a:ln/>
-        </p:spPr>
-        <p:txBody>
-          <a:bodyPr wrap="square" lIns="0" tIns="0" rIns="0" bIns="0" rtlCol="0" anchor="ctr"/>
-          <a:lstStyle/>
-          <a:p>
-            <a:pPr indent="0" marL="0">
-              <a:lnSpc>
-                <a:spcPts val="1600"/>
-              </a:lnSpc>
-              <a:buNone/>
-            </a:pPr>
-            <a:r>
-              <a:rPr lang="en-US" sz="1450" b="1" dirty="0">
-                <a:solidFill>
-                  <a:srgbClr val="0B2545"/>
-                </a:solidFill>
-                <a:latin typeface="Calibri" pitchFamily="34" charset="0"/>
-                <a:ea typeface="Calibri" pitchFamily="34" charset="-122"/>
-                <a:cs typeface="Calibri" pitchFamily="34" charset="-120"/>
-              </a:rPr>
-              <a:t>Cross-layer 413</a:t>
-            </a:r>
-            <a:endParaRPr lang="en-US" sz="1450" dirty="0"/>
-          </a:p>
-        </p:txBody>
-      </p:sp>
-      <p:sp>
-        <p:nvSpPr>
-          <p:cNvPr id="22" name="Text 16"/>
-          <p:cNvSpPr/>
-          <p:nvPr/>
-        </p:nvSpPr>
-        <p:spPr>
-          <a:xfrm>
-            <a:off x="758952" y="4773168"/>
-            <a:ext cx="3145536" cy="1005840"/>
-          </a:xfrm>
-          <a:prstGeom prst="rect">
-            <a:avLst/>
-          </a:prstGeom>
-          <a:noFill/>
-          <a:ln/>
-        </p:spPr>
-        <p:txBody>
-          <a:bodyPr wrap="square" lIns="0" tIns="0" rIns="0" bIns="0" rtlCol="0" anchor="ctr"/>
-          <a:lstStyle/>
-          <a:p>
-            <a:pPr indent="0" marL="0">
-              <a:lnSpc>
-                <a:spcPts val="1450"/>
-              </a:lnSpc>
-              <a:buNone/>
-            </a:pPr>
-            <a:r>
-              <a:rPr lang="en-US" sz="1150" dirty="0">
-                <a:solidFill>
-                  <a:srgbClr val="5B6B7F"/>
-                </a:solidFill>
-                <a:latin typeface="Calibri" pitchFamily="34" charset="0"/>
-                <a:ea typeface="Calibri" pitchFamily="34" charset="-122"/>
-                <a:cs typeface="Calibri" pitchFamily="34" charset="-120"/>
-              </a:rPr>
-              <a:t>OOB agent submits national polygons as a spatial filter → 413. Fix: state-scope the prompt or pre-compute the attribute.</a:t>
-            </a:r>
-            <a:endParaRPr lang="en-US" sz="1150" dirty="0"/>
-          </a:p>
-        </p:txBody>
-      </p:sp>
-      <p:sp>
-        <p:nvSpPr>
-          <p:cNvPr id="23" name="Shape 17"/>
-          <p:cNvSpPr/>
-          <p:nvPr/>
-        </p:nvSpPr>
-        <p:spPr>
-          <a:xfrm>
-            <a:off x="4398264" y="3749040"/>
-            <a:ext cx="3657600" cy="2148840"/>
-          </a:xfrm>
-          <a:prstGeom prst="roundRect">
-            <a:avLst>
-              <a:gd name="adj" fmla="val 3404"/>
-            </a:avLst>
-          </a:prstGeom>
-          <a:solidFill>
-            <a:srgbClr val="F4F7FA"/>
-          </a:solidFill>
-          <a:ln/>
-          <a:effectLst>
-            <a:outerShdw sx="100000" sy="100000" kx="0" ky="0" algn="bl" rotWithShape="0" blurRad="88900" dist="38100" dir="5400000">
-              <a:srgbClr val="000000">
-                <a:alpha val="12000"/>
-              </a:srgbClr>
-            </a:outerShdw>
-          </a:effectLst>
-        </p:spPr>
-      </p:sp>
-      <p:sp>
-        <p:nvSpPr>
-          <p:cNvPr id="24" name="Shape 18"/>
-          <p:cNvSpPr/>
-          <p:nvPr/>
-        </p:nvSpPr>
-        <p:spPr>
-          <a:xfrm>
-            <a:off x="4654296" y="4005072"/>
-            <a:ext cx="713232" cy="713232"/>
-          </a:xfrm>
-          <a:prstGeom prst="ellipse">
-            <a:avLst/>
-          </a:prstGeom>
-          <a:solidFill>
-            <a:srgbClr val="E8A33D"/>
-          </a:solidFill>
-          <a:ln/>
-        </p:spPr>
-      </p:sp>
-      <p:pic>
-        <p:nvPicPr>
-          <p:cNvPr id="25" name="Image 4" descr="preencoded.png">    </p:cNvPr>
-          <p:cNvPicPr>
-            <a:picLocks noChangeAspect="1"/>
-          </p:cNvPicPr>
-          <p:nvPr/>
-        </p:nvPicPr>
-        <p:blipFill>
-          <a:blip r:embed="rId5"/>
-          <a:stretch>
-            <a:fillRect/>
-          </a:stretch>
-        </p:blipFill>
-        <p:spPr>
-          <a:xfrm>
-            <a:off x="4839736" y="4190512"/>
-            <a:ext cx="342351" cy="342351"/>
-          </a:xfrm>
-          <a:prstGeom prst="rect">
-            <a:avLst/>
-          </a:prstGeom>
-        </p:spPr>
-      </p:pic>
-      <p:sp>
-        <p:nvSpPr>
-          <p:cNvPr id="26" name="Text 19"/>
-          <p:cNvSpPr/>
-          <p:nvPr/>
-        </p:nvSpPr>
-        <p:spPr>
-          <a:xfrm>
-            <a:off x="5495544" y="4023360"/>
-            <a:ext cx="2377440" cy="685800"/>
-          </a:xfrm>
-          <a:prstGeom prst="rect">
-            <a:avLst/>
-          </a:prstGeom>
-          <a:noFill/>
-          <a:ln/>
-        </p:spPr>
-        <p:txBody>
-          <a:bodyPr wrap="square" lIns="0" tIns="0" rIns="0" bIns="0" rtlCol="0" anchor="ctr"/>
-          <a:lstStyle/>
-          <a:p>
-            <a:pPr indent="0" marL="0">
-              <a:lnSpc>
-                <a:spcPts val="1600"/>
-              </a:lnSpc>
-              <a:buNone/>
-            </a:pPr>
-            <a:r>
-              <a:rPr lang="en-US" sz="1450" b="1" dirty="0">
-                <a:solidFill>
-                  <a:srgbClr val="0B2545"/>
-                </a:solidFill>
-                <a:latin typeface="Calibri" pitchFamily="34" charset="0"/>
-                <a:ea typeface="Calibri" pitchFamily="34" charset="-122"/>
-                <a:cs typeface="Calibri" pitchFamily="34" charset="-120"/>
-              </a:rPr>
-              <a:t>Schema introspection lies</a:t>
-            </a:r>
-            <a:endParaRPr lang="en-US" sz="1450" dirty="0"/>
-          </a:p>
-        </p:txBody>
-      </p:sp>
-      <p:sp>
-        <p:nvSpPr>
-          <p:cNvPr id="27" name="Text 20"/>
-          <p:cNvSpPr/>
-          <p:nvPr/>
-        </p:nvSpPr>
-        <p:spPr>
-          <a:xfrm>
-            <a:off x="4654296" y="4773168"/>
-            <a:ext cx="3145536" cy="1005840"/>
-          </a:xfrm>
-          <a:prstGeom prst="rect">
-            <a:avLst/>
-          </a:prstGeom>
-          <a:noFill/>
-          <a:ln/>
-        </p:spPr>
-        <p:txBody>
-          <a:bodyPr wrap="square" lIns="0" tIns="0" rIns="0" bIns="0" rtlCol="0" anchor="ctr"/>
-          <a:lstStyle/>
-          <a:p>
-            <a:pPr indent="0" marL="0">
-              <a:lnSpc>
-                <a:spcPts val="1450"/>
-              </a:lnSpc>
-              <a:buNone/>
-            </a:pPr>
-            <a:r>
-              <a:rPr lang="en-US" sz="1150" dirty="0">
-                <a:solidFill>
-                  <a:srgbClr val="5B6B7F"/>
-                </a:solidFill>
-                <a:latin typeface="Calibri" pitchFamily="34" charset="0"/>
-                <a:ea typeface="Calibri" pitchFamily="34" charset="-122"/>
-                <a:cs typeface="Calibri" pitchFamily="34" charset="-120"/>
-              </a:rPr>
-              <a:t>"List fields" returned two contradictory lists in one turn. Verify schema via AGO Data → Fields — never the assistant.</a:t>
-            </a:r>
-            <a:endParaRPr lang="en-US" sz="1150" dirty="0"/>
-          </a:p>
-        </p:txBody>
-      </p:sp>
-      <p:sp>
-        <p:nvSpPr>
-          <p:cNvPr id="28" name="Shape 21"/>
-          <p:cNvSpPr/>
-          <p:nvPr/>
-        </p:nvSpPr>
-        <p:spPr>
-          <a:xfrm>
-            <a:off x="8293608" y="3749040"/>
-            <a:ext cx="3657600" cy="2148840"/>
-          </a:xfrm>
-          <a:prstGeom prst="roundRect">
-            <a:avLst>
-              <a:gd name="adj" fmla="val 3404"/>
-            </a:avLst>
-          </a:prstGeom>
-          <a:solidFill>
-            <a:srgbClr val="F4F7FA"/>
-          </a:solidFill>
-          <a:ln/>
-          <a:effectLst>
-            <a:outerShdw sx="100000" sy="100000" kx="0" ky="0" algn="bl" rotWithShape="0" blurRad="88900" dist="38100" dir="5400000">
-              <a:srgbClr val="000000">
-                <a:alpha val="12000"/>
-              </a:srgbClr>
-            </a:outerShdw>
-          </a:effectLst>
-        </p:spPr>
-      </p:sp>
-      <p:sp>
-        <p:nvSpPr>
-          <p:cNvPr id="29" name="Shape 22"/>
-          <p:cNvSpPr/>
-          <p:nvPr/>
-        </p:nvSpPr>
-        <p:spPr>
-          <a:xfrm>
-            <a:off x="8549640" y="4005072"/>
-            <a:ext cx="713232" cy="713232"/>
-          </a:xfrm>
-          <a:prstGeom prst="ellipse">
-            <a:avLst/>
-          </a:prstGeom>
-          <a:solidFill>
-            <a:srgbClr val="E8A33D"/>
-          </a:solidFill>
-          <a:ln/>
-        </p:spPr>
-      </p:sp>
-      <p:pic>
-        <p:nvPicPr>
-          <p:cNvPr id="30" name="Image 5" descr="preencoded.png">    </p:cNvPr>
-          <p:cNvPicPr>
-            <a:picLocks noChangeAspect="1"/>
-          </p:cNvPicPr>
-          <p:nvPr/>
-        </p:nvPicPr>
-        <p:blipFill>
-          <a:blip r:embed="rId6"/>
-          <a:stretch>
-            <a:fillRect/>
-          </a:stretch>
-        </p:blipFill>
-        <p:spPr>
-          <a:xfrm>
-            <a:off x="8735080" y="4190512"/>
-            <a:ext cx="342351" cy="342351"/>
-          </a:xfrm>
-          <a:prstGeom prst="rect">
-            <a:avLst/>
-          </a:prstGeom>
-        </p:spPr>
-      </p:pic>
-      <p:sp>
-        <p:nvSpPr>
-          <p:cNvPr id="31" name="Text 23"/>
-          <p:cNvSpPr/>
-          <p:nvPr/>
-        </p:nvSpPr>
-        <p:spPr>
-          <a:xfrm>
-            <a:off x="9390888" y="4023360"/>
-            <a:ext cx="2377440" cy="685800"/>
-          </a:xfrm>
-          <a:prstGeom prst="rect">
-            <a:avLst/>
-          </a:prstGeom>
-          <a:noFill/>
-          <a:ln/>
-        </p:spPr>
-        <p:txBody>
-          <a:bodyPr wrap="square" lIns="0" tIns="0" rIns="0" bIns="0" rtlCol="0" anchor="ctr"/>
-          <a:lstStyle/>
-          <a:p>
-            <a:pPr indent="0" marL="0">
-              <a:lnSpc>
-                <a:spcPts val="1600"/>
-              </a:lnSpc>
-              <a:buNone/>
-            </a:pPr>
-            <a:r>
-              <a:rPr lang="en-US" sz="1450" b="1" dirty="0">
-                <a:solidFill>
-                  <a:srgbClr val="0B2545"/>
-                </a:solidFill>
-                <a:latin typeface="Calibri" pitchFamily="34" charset="0"/>
-                <a:ea typeface="Calibri" pitchFamily="34" charset="-122"/>
-                <a:cs typeface="Calibri" pitchFamily="34" charset="-120"/>
-              </a:rPr>
-              <a:t>Verify, don't infer</a:t>
-            </a:r>
-            <a:endParaRPr lang="en-US" sz="1450" dirty="0"/>
-          </a:p>
-        </p:txBody>
-      </p:sp>
-      <p:sp>
-        <p:nvSpPr>
-          <p:cNvPr id="32" name="Text 24"/>
-          <p:cNvSpPr/>
-          <p:nvPr/>
-        </p:nvSpPr>
-        <p:spPr>
-          <a:xfrm>
-            <a:off x="8549640" y="4773168"/>
-            <a:ext cx="3145536" cy="1005840"/>
-          </a:xfrm>
-          <a:prstGeom prst="rect">
-            <a:avLst/>
-          </a:prstGeom>
-          <a:noFill/>
-          <a:ln/>
-        </p:spPr>
-        <p:txBody>
-          <a:bodyPr wrap="square" lIns="0" tIns="0" rIns="0" bIns="0" rtlCol="0" anchor="ctr"/>
-          <a:lstStyle/>
-          <a:p>
-            <a:pPr indent="0" marL="0">
-              <a:lnSpc>
-                <a:spcPts val="1450"/>
-              </a:lnSpc>
-              <a:buNone/>
-            </a:pPr>
-            <a:r>
-              <a:rPr lang="en-US" sz="1150" dirty="0">
-                <a:solidFill>
-                  <a:srgbClr val="5B6B7F"/>
-                </a:solidFill>
-                <a:latin typeface="Calibri" pitchFamily="34" charset="0"/>
-                <a:ea typeface="Calibri" pitchFamily="34" charset="-122"/>
-                <a:cs typeface="Calibri" pitchFamily="34" charset="-120"/>
-              </a:rPr>
-              <a:t>Filenames in dist/ aren't docs. We mounted a non-existent agent on a guess. Confirm against developers.arcgis.com.</a:t>
-            </a:r>
-            <a:endParaRPr lang="en-US" sz="1150" dirty="0"/>
-          </a:p>
-        </p:txBody>
-      </p:sp>
-      <p:sp>
-        <p:nvSpPr>
-          <p:cNvPr id="33" name="Text 25"/>
+              <a:rPr lang="en-US" sz="1300" dirty="0">
+                <a:solidFill>
+                  <a:srgbClr val="C9D6E5"/>
+                </a:solidFill>
+                <a:latin typeface="Calibri" pitchFamily="34" charset="0"/>
+                <a:ea typeface="Calibri" pitchFamily="34" charset="-122"/>
+                <a:cs typeface="Calibri" pitchFamily="34" charset="-120"/>
+              </a:rPr>
+              <a:t>www.arcgis.com (generic sign-in)  vs  https://&lt;org-key&gt;.maps.arcgis.com (targets your org → routes SAML members to your IdP).</a:t>
+            </a:r>
+            <a:endParaRPr lang="en-US" sz="1300" dirty="0"/>
+          </a:p>
+        </p:txBody>
+      </p:sp>
+      <p:sp>
+        <p:nvSpPr>
+          <p:cNvPr id="16" name="Text 12"/>
           <p:cNvSpPr/>
           <p:nvPr/>
         </p:nvSpPr>
@@ -8058,7 +8642,7 @@
       </p:sp>
       <p:sp>
         <p:nvSpPr>
-          <p:cNvPr id="34" name="Text 26"/>
+          <p:cNvPr id="17" name="Text 13"/>
           <p:cNvSpPr/>
           <p:nvPr/>
         </p:nvSpPr>
@@ -8136,7 +8720,7 @@
         <p:spPr>
           <a:xfrm>
             <a:off x="502920" y="411480"/>
-            <a:ext cx="11155680" cy="640080"/>
+            <a:ext cx="10972800" cy="640080"/>
           </a:xfrm>
           <a:prstGeom prst="rect">
             <a:avLst/>
@@ -8152,7 +8736,7 @@
               <a:buNone/>
             </a:pPr>
             <a:r>
-              <a:rPr lang="en-US" sz="2800" b="1" dirty="0">
+              <a:rPr lang="en-US" sz="3000" b="1" dirty="0">
                 <a:solidFill>
                   <a:srgbClr val="0B2545"/>
                 </a:solidFill>
@@ -8160,9 +8744,9 @@
                 <a:ea typeface="Bookman Old Style" pitchFamily="34" charset="-122"/>
                 <a:cs typeface="Bookman Old Style" pitchFamily="34" charset="-120"/>
               </a:rPr>
-              <a:t>Prompt engineering: what the OOB agent can do</a:t>
-            </a:r>
-            <a:endParaRPr lang="en-US" sz="2800" dirty="0"/>
+              <a:t>Gotchas that cost us a day</a:t>
+            </a:r>
+            <a:endParaRPr lang="en-US" sz="3000" dirty="0"/>
           </a:p>
         </p:txBody>
       </p:sp>
@@ -8174,16 +8758,16 @@
         </p:nvSpPr>
         <p:spPr>
           <a:xfrm>
-            <a:off x="502920" y="1371600"/>
-            <a:ext cx="5486400" cy="4572000"/>
+            <a:off x="502920" y="1325880"/>
+            <a:ext cx="3657600" cy="2148840"/>
           </a:xfrm>
           <a:prstGeom prst="roundRect">
             <a:avLst>
-              <a:gd name="adj" fmla="val 2000"/>
+              <a:gd name="adj" fmla="val 3404"/>
             </a:avLst>
           </a:prstGeom>
           <a:solidFill>
-            <a:srgbClr val="EAF4EF"/>
+            <a:srgbClr val="F4F7FA"/>
           </a:solidFill>
           <a:ln/>
           <a:effectLst>
@@ -8203,14 +8787,14 @@
         </p:nvSpPr>
         <p:spPr>
           <a:xfrm>
-            <a:off x="822960" y="1645920"/>
-            <a:ext cx="731520" cy="731520"/>
+            <a:off x="758952" y="1581912"/>
+            <a:ext cx="713232" cy="713232"/>
           </a:xfrm>
           <a:prstGeom prst="ellipse">
             <a:avLst/>
           </a:prstGeom>
           <a:solidFill>
-            <a:srgbClr val="2A9D6F"/>
+            <a:srgbClr val="E8A33D"/>
           </a:solidFill>
           <a:ln/>
         </p:spPr>
@@ -8231,8 +8815,8 @@
         </p:blipFill>
         <p:spPr>
           <a:xfrm>
-            <a:off x="1013155" y="1836115"/>
-            <a:ext cx="351130" cy="351130"/>
+            <a:off x="944392" y="1767352"/>
+            <a:ext cx="342351" cy="342351"/>
           </a:xfrm>
           <a:prstGeom prst="rect">
             <a:avLst/>
@@ -8247,8 +8831,8 @@
         </p:nvSpPr>
         <p:spPr>
           <a:xfrm>
-            <a:off x="1691640" y="1645920"/>
-            <a:ext cx="4114800" cy="731520"/>
+            <a:off x="1600200" y="1600200"/>
+            <a:ext cx="2377440" cy="685800"/>
           </a:xfrm>
           <a:prstGeom prst="rect">
             <a:avLst/>
@@ -8261,20 +8845,23 @@
           <a:lstStyle/>
           <a:p>
             <a:pPr indent="0" marL="0">
-              <a:buNone/>
-            </a:pPr>
-            <a:r>
-              <a:rPr lang="en-US" sz="1800" b="1" dirty="0">
-                <a:solidFill>
-                  <a:srgbClr val="2A9D6F"/>
-                </a:solidFill>
-                <a:latin typeface="Calibri" pitchFamily="34" charset="0"/>
-                <a:ea typeface="Calibri" pitchFamily="34" charset="-122"/>
-                <a:cs typeface="Calibri" pitchFamily="34" charset="-120"/>
-              </a:rPr>
-              <a:t>Reliable — demo these</a:t>
-            </a:r>
-            <a:endParaRPr lang="en-US" sz="1800" dirty="0"/>
+              <a:lnSpc>
+                <a:spcPts val="1600"/>
+              </a:lnSpc>
+              <a:buNone/>
+            </a:pPr>
+            <a:r>
+              <a:rPr lang="en-US" sz="1450" b="1" dirty="0">
+                <a:solidFill>
+                  <a:srgbClr val="0B2545"/>
+                </a:solidFill>
+                <a:latin typeface="Calibri" pitchFamily="34" charset="0"/>
+                <a:ea typeface="Calibri" pitchFamily="34" charset="-122"/>
+                <a:cs typeface="Calibri" pitchFamily="34" charset="-120"/>
+              </a:rPr>
+              <a:t>Elements don't auto-register</a:t>
+            </a:r>
+            <a:endParaRPr lang="en-US" sz="1450" dirty="0"/>
           </a:p>
         </p:txBody>
       </p:sp>
@@ -8286,137 +8873,37 @@
         </p:nvSpPr>
         <p:spPr>
           <a:xfrm>
-            <a:off x="868680" y="2651760"/>
-            <a:ext cx="4937760" cy="3108960"/>
-          </a:xfrm>
-          <a:prstGeom prst="rect">
-            <a:avLst/>
-          </a:prstGeom>
-          <a:noFill/>
-          <a:ln/>
-        </p:spPr>
-        <p:txBody>
-          <a:bodyPr wrap="square" lIns="0" tIns="0" rIns="0" bIns="0" rtlCol="0" anchor="ctr"/>
-          <a:lstStyle/>
-          <a:p>
-            <a:pPr marL="342900" indent="-342900">
+            <a:off x="758952" y="2350008"/>
+            <a:ext cx="3145536" cy="1005840"/>
+          </a:xfrm>
+          <a:prstGeom prst="rect">
+            <a:avLst/>
+          </a:prstGeom>
+          <a:noFill/>
+          <a:ln/>
+        </p:spPr>
+        <p:txBody>
+          <a:bodyPr wrap="square" lIns="0" tIns="0" rIns="0" bIns="0" rtlCol="0" anchor="ctr"/>
+          <a:lstStyle/>
+          <a:p>
+            <a:pPr indent="0" marL="0">
               <a:lnSpc>
-                <a:spcPts val="2200"/>
+                <a:spcPts val="1450"/>
               </a:lnSpc>
-              <a:spcAft>
-                <a:spcPts val="1200"/>
-              </a:spcAft>
-              <a:buSzPct val="100000"/>
-              <a:buChar char="•"/>
-            </a:pPr>
-            <a:r>
-              <a:rPr lang="en-US" sz="1350" dirty="0">
-                <a:solidFill>
-                  <a:srgbClr val="1E293B"/>
-                </a:solidFill>
-                <a:latin typeface="Calibri" pitchFamily="34" charset="0"/>
-                <a:ea typeface="Calibri" pitchFamily="34" charset="-122"/>
-                <a:cs typeface="Calibri" pitchFamily="34" charset="-120"/>
-              </a:rPr>
-              <a:t>Attribute filters  ("show the high-priority records")</a:t>
-            </a:r>
-            <a:endParaRPr lang="en-US" sz="1350" dirty="0"/>
-          </a:p>
-          <a:p>
-            <a:pPr marL="342900" indent="-342900">
-              <a:lnSpc>
-                <a:spcPts val="2200"/>
-              </a:lnSpc>
-              <a:spcAft>
-                <a:spcPts val="1200"/>
-              </a:spcAft>
-              <a:buSzPct val="100000"/>
-              <a:buChar char="•"/>
-            </a:pPr>
-            <a:r>
-              <a:rPr lang="en-US" sz="1350" dirty="0">
-                <a:solidFill>
-                  <a:srgbClr val="1E293B"/>
-                </a:solidFill>
-                <a:latin typeface="Calibri" pitchFamily="34" charset="0"/>
-                <a:ea typeface="Calibri" pitchFamily="34" charset="-122"/>
-                <a:cs typeface="Calibri" pitchFamily="34" charset="-120"/>
-              </a:rPr>
-              <a:t>Single-group stats  ("average metric for a group")</a:t>
-            </a:r>
-            <a:endParaRPr lang="en-US" sz="1350" dirty="0"/>
-          </a:p>
-          <a:p>
-            <a:pPr marL="342900" indent="-342900">
-              <a:lnSpc>
-                <a:spcPts val="2200"/>
-              </a:lnSpc>
-              <a:spcAft>
-                <a:spcPts val="1200"/>
-              </a:spcAft>
-              <a:buSzPct val="100000"/>
-              <a:buChar char="•"/>
-            </a:pPr>
-            <a:r>
-              <a:rPr lang="en-US" sz="1350" dirty="0">
-                <a:solidFill>
-                  <a:srgbClr val="1E293B"/>
-                </a:solidFill>
-                <a:latin typeface="Calibri" pitchFamily="34" charset="0"/>
-                <a:ea typeface="Calibri" pitchFamily="34" charset="-122"/>
-                <a:cs typeface="Calibri" pitchFamily="34" charset="-120"/>
-              </a:rPr>
-              <a:t>Multi-attribute combos  (filter on two fields)</a:t>
-            </a:r>
-            <a:endParaRPr lang="en-US" sz="1350" dirty="0"/>
-          </a:p>
-          <a:p>
-            <a:pPr marL="342900" indent="-342900">
-              <a:lnSpc>
-                <a:spcPts val="2200"/>
-              </a:lnSpc>
-              <a:spcAft>
-                <a:spcPts val="1200"/>
-              </a:spcAft>
-              <a:buSzPct val="100000"/>
-              <a:buChar char="•"/>
-            </a:pPr>
-            <a:r>
-              <a:rPr lang="en-US" sz="1350" dirty="0">
-                <a:solidFill>
-                  <a:srgbClr val="1E293B"/>
-                </a:solidFill>
-                <a:latin typeface="Calibri" pitchFamily="34" charset="0"/>
-                <a:ea typeface="Calibri" pitchFamily="34" charset="-122"/>
-                <a:cs typeface="Calibri" pitchFamily="34" charset="-120"/>
-              </a:rPr>
-              <a:t>State / region-scoped cross-layer intersects</a:t>
-            </a:r>
-            <a:endParaRPr lang="en-US" sz="1350" dirty="0"/>
-          </a:p>
-          <a:p>
-            <a:pPr marL="342900" indent="-342900">
-              <a:lnSpc>
-                <a:spcPts val="2200"/>
-              </a:lnSpc>
-              <a:spcAft>
-                <a:spcPts val="1200"/>
-              </a:spcAft>
-              <a:buSzPct val="100000"/>
-              <a:buChar char="•"/>
-            </a:pPr>
-            <a:r>
-              <a:rPr lang="en-US" sz="1350" dirty="0">
-                <a:solidFill>
-                  <a:srgbClr val="1E293B"/>
-                </a:solidFill>
-                <a:latin typeface="Calibri" pitchFamily="34" charset="0"/>
-                <a:ea typeface="Calibri" pitchFamily="34" charset="-122"/>
-                <a:cs typeface="Calibri" pitchFamily="34" charset="-120"/>
-              </a:rPr>
-              <a:t>Pointed, single-subject questions</a:t>
-            </a:r>
-            <a:endParaRPr lang="en-US" sz="1350" dirty="0"/>
+              <a:buNone/>
+            </a:pPr>
+            <a:r>
+              <a:rPr lang="en-US" sz="1150" dirty="0">
+                <a:solidFill>
+                  <a:srgbClr val="5B6B7F"/>
+                </a:solidFill>
+                <a:latin typeface="Calibri" pitchFamily="34" charset="0"/>
+                <a:ea typeface="Calibri" pitchFamily="34" charset="-122"/>
+                <a:cs typeface="Calibri" pitchFamily="34" charset="-120"/>
+              </a:rPr>
+              <a:t>SDK 5.x is Lumina-based. Bare imports do nothing — call defineCustomElements() or you get "Custom element not found."</a:t>
+            </a:r>
+            <a:endParaRPr lang="en-US" sz="1150" dirty="0"/>
           </a:p>
         </p:txBody>
       </p:sp>
@@ -8428,16 +8915,16 @@
         </p:nvSpPr>
         <p:spPr>
           <a:xfrm>
-            <a:off x="6217920" y="1371600"/>
-            <a:ext cx="5486400" cy="4572000"/>
+            <a:off x="4398264" y="1325880"/>
+            <a:ext cx="3657600" cy="2148840"/>
           </a:xfrm>
           <a:prstGeom prst="roundRect">
             <a:avLst>
-              <a:gd name="adj" fmla="val 2000"/>
+              <a:gd name="adj" fmla="val 3404"/>
             </a:avLst>
           </a:prstGeom>
           <a:solidFill>
-            <a:srgbClr val="FBEDEC"/>
+            <a:srgbClr val="F4F7FA"/>
           </a:solidFill>
           <a:ln/>
           <a:effectLst>
@@ -8457,14 +8944,14 @@
         </p:nvSpPr>
         <p:spPr>
           <a:xfrm>
-            <a:off x="6537960" y="1645920"/>
-            <a:ext cx="731520" cy="731520"/>
+            <a:off x="4654296" y="1581912"/>
+            <a:ext cx="713232" cy="713232"/>
           </a:xfrm>
           <a:prstGeom prst="ellipse">
             <a:avLst/>
           </a:prstGeom>
           <a:solidFill>
-            <a:srgbClr val="C24A45"/>
+            <a:srgbClr val="E8A33D"/>
           </a:solidFill>
           <a:ln/>
         </p:spPr>
@@ -8485,8 +8972,8 @@
         </p:blipFill>
         <p:spPr>
           <a:xfrm>
-            <a:off x="6728155" y="1836115"/>
-            <a:ext cx="351130" cy="351130"/>
+            <a:off x="4839736" y="1767352"/>
+            <a:ext cx="342351" cy="342351"/>
           </a:xfrm>
           <a:prstGeom prst="rect">
             <a:avLst/>
@@ -8501,8 +8988,8 @@
         </p:nvSpPr>
         <p:spPr>
           <a:xfrm>
-            <a:off x="7406640" y="1645920"/>
-            <a:ext cx="4114800" cy="731520"/>
+            <a:off x="5495544" y="1600200"/>
+            <a:ext cx="2377440" cy="685800"/>
           </a:xfrm>
           <a:prstGeom prst="rect">
             <a:avLst/>
@@ -8515,20 +9002,23 @@
           <a:lstStyle/>
           <a:p>
             <a:pPr indent="0" marL="0">
-              <a:buNone/>
-            </a:pPr>
-            <a:r>
-              <a:rPr lang="en-US" sz="1800" b="1" dirty="0">
-                <a:solidFill>
-                  <a:srgbClr val="C24A45"/>
-                </a:solidFill>
-                <a:latin typeface="Calibri" pitchFamily="34" charset="0"/>
-                <a:ea typeface="Calibri" pitchFamily="34" charset="-122"/>
-                <a:cs typeface="Calibri" pitchFamily="34" charset="-120"/>
-              </a:rPr>
-              <a:t>Fails / degrades — keep out</a:t>
-            </a:r>
-            <a:endParaRPr lang="en-US" sz="1800" dirty="0"/>
+              <a:lnSpc>
+                <a:spcPts val="1600"/>
+              </a:lnSpc>
+              <a:buNone/>
+            </a:pPr>
+            <a:r>
+              <a:rPr lang="en-US" sz="1450" b="1" dirty="0">
+                <a:solidFill>
+                  <a:srgbClr val="0B2545"/>
+                </a:solidFill>
+                <a:latin typeface="Calibri" pitchFamily="34" charset="0"/>
+                <a:ea typeface="Calibri" pitchFamily="34" charset="-122"/>
+                <a:cs typeface="Calibri" pitchFamily="34" charset="-120"/>
+              </a:rPr>
+              <a:t>No ai-components-react</a:t>
+            </a:r>
+            <a:endParaRPr lang="en-US" sz="1450" dirty="0"/>
           </a:p>
         </p:txBody>
       </p:sp>
@@ -8540,143 +9030,671 @@
         </p:nvSpPr>
         <p:spPr>
           <a:xfrm>
-            <a:off x="6583680" y="2651760"/>
-            <a:ext cx="4937760" cy="3108960"/>
-          </a:xfrm>
-          <a:prstGeom prst="rect">
-            <a:avLst/>
-          </a:prstGeom>
-          <a:noFill/>
-          <a:ln/>
-        </p:spPr>
-        <p:txBody>
-          <a:bodyPr wrap="square" lIns="0" tIns="0" rIns="0" bIns="0" rtlCol="0" anchor="ctr"/>
-          <a:lstStyle/>
-          <a:p>
-            <a:pPr marL="342900" indent="-342900">
+            <a:off x="4654296" y="2350008"/>
+            <a:ext cx="3145536" cy="1005840"/>
+          </a:xfrm>
+          <a:prstGeom prst="rect">
+            <a:avLst/>
+          </a:prstGeom>
+          <a:noFill/>
+          <a:ln/>
+        </p:spPr>
+        <p:txBody>
+          <a:bodyPr wrap="square" lIns="0" tIns="0" rIns="0" bIns="0" rtlCol="0" anchor="ctr"/>
+          <a:lstStyle/>
+          <a:p>
+            <a:pPr indent="0" marL="0">
               <a:lnSpc>
-                <a:spcPts val="2200"/>
+                <a:spcPts val="1450"/>
               </a:lnSpc>
-              <a:spcAft>
-                <a:spcPts val="1200"/>
-              </a:spcAft>
-              <a:buSzPct val="100000"/>
-              <a:buChar char="•"/>
-            </a:pPr>
-            <a:r>
-              <a:rPr lang="en-US" sz="1350" dirty="0">
-                <a:solidFill>
-                  <a:srgbClr val="1E293B"/>
-                </a:solidFill>
-                <a:latin typeface="Calibri" pitchFamily="34" charset="0"/>
-                <a:ea typeface="Calibri" pitchFamily="34" charset="-122"/>
-                <a:cs typeface="Calibri" pitchFamily="34" charset="-120"/>
-              </a:rPr>
-              <a:t>Schema introspection  ("list fields") — hallucinates</a:t>
-            </a:r>
-            <a:endParaRPr lang="en-US" sz="1350" dirty="0"/>
-          </a:p>
-          <a:p>
-            <a:pPr marL="342900" indent="-342900">
+              <a:buNone/>
+            </a:pPr>
+            <a:r>
+              <a:rPr lang="en-US" sz="1150" dirty="0">
+                <a:solidFill>
+                  <a:srgbClr val="5B6B7F"/>
+                </a:solidFill>
+                <a:latin typeface="Calibri" pitchFamily="34" charset="0"/>
+                <a:ea typeface="Calibri" pitchFamily="34" charset="-122"/>
+                <a:cs typeface="Calibri" pitchFamily="34" charset="-120"/>
+              </a:rPr>
+              <a:t>AI components ship as raw web components only. Declare the tags in vite-env.d.ts; set props imperatively via refs.</a:t>
+            </a:r>
+            <a:endParaRPr lang="en-US" sz="1150" dirty="0"/>
+          </a:p>
+        </p:txBody>
+      </p:sp>
+      <p:sp>
+        <p:nvSpPr>
+          <p:cNvPr id="13" name="Shape 9"/>
+          <p:cNvSpPr/>
+          <p:nvPr/>
+        </p:nvSpPr>
+        <p:spPr>
+          <a:xfrm>
+            <a:off x="8293608" y="1325880"/>
+            <a:ext cx="3657600" cy="2148840"/>
+          </a:xfrm>
+          <a:prstGeom prst="roundRect">
+            <a:avLst>
+              <a:gd name="adj" fmla="val 3404"/>
+            </a:avLst>
+          </a:prstGeom>
+          <a:solidFill>
+            <a:srgbClr val="F4F7FA"/>
+          </a:solidFill>
+          <a:ln/>
+          <a:effectLst>
+            <a:outerShdw sx="100000" sy="100000" kx="0" ky="0" algn="bl" rotWithShape="0" blurRad="88900" dist="38100" dir="5400000">
+              <a:srgbClr val="000000">
+                <a:alpha val="12000"/>
+              </a:srgbClr>
+            </a:outerShdw>
+          </a:effectLst>
+        </p:spPr>
+      </p:sp>
+      <p:sp>
+        <p:nvSpPr>
+          <p:cNvPr id="14" name="Shape 10"/>
+          <p:cNvSpPr/>
+          <p:nvPr/>
+        </p:nvSpPr>
+        <p:spPr>
+          <a:xfrm>
+            <a:off x="8549640" y="1581912"/>
+            <a:ext cx="713232" cy="713232"/>
+          </a:xfrm>
+          <a:prstGeom prst="ellipse">
+            <a:avLst/>
+          </a:prstGeom>
+          <a:solidFill>
+            <a:srgbClr val="E8A33D"/>
+          </a:solidFill>
+          <a:ln/>
+        </p:spPr>
+      </p:sp>
+      <p:pic>
+        <p:nvPicPr>
+          <p:cNvPr id="15" name="Image 2" descr="preencoded.png">    </p:cNvPr>
+          <p:cNvPicPr>
+            <a:picLocks noChangeAspect="1"/>
+          </p:cNvPicPr>
+          <p:nvPr/>
+        </p:nvPicPr>
+        <p:blipFill>
+          <a:blip r:embed="rId3"/>
+          <a:stretch>
+            <a:fillRect/>
+          </a:stretch>
+        </p:blipFill>
+        <p:spPr>
+          <a:xfrm>
+            <a:off x="8735080" y="1767352"/>
+            <a:ext cx="342351" cy="342351"/>
+          </a:xfrm>
+          <a:prstGeom prst="rect">
+            <a:avLst/>
+          </a:prstGeom>
+        </p:spPr>
+      </p:pic>
+      <p:sp>
+        <p:nvSpPr>
+          <p:cNvPr id="16" name="Text 11"/>
+          <p:cNvSpPr/>
+          <p:nvPr/>
+        </p:nvSpPr>
+        <p:spPr>
+          <a:xfrm>
+            <a:off x="9390888" y="1600200"/>
+            <a:ext cx="2377440" cy="685800"/>
+          </a:xfrm>
+          <a:prstGeom prst="rect">
+            <a:avLst/>
+          </a:prstGeom>
+          <a:noFill/>
+          <a:ln/>
+        </p:spPr>
+        <p:txBody>
+          <a:bodyPr wrap="square" lIns="0" tIns="0" rIns="0" bIns="0" rtlCol="0" anchor="ctr"/>
+          <a:lstStyle/>
+          <a:p>
+            <a:pPr indent="0" marL="0">
               <a:lnSpc>
-                <a:spcPts val="2200"/>
+                <a:spcPts val="1600"/>
               </a:lnSpc>
-              <a:spcAft>
-                <a:spcPts val="1200"/>
-              </a:spcAft>
-              <a:buSzPct val="100000"/>
-              <a:buChar char="•"/>
-            </a:pPr>
-            <a:r>
-              <a:rPr lang="en-US" sz="1350" dirty="0">
-                <a:solidFill>
-                  <a:srgbClr val="1E293B"/>
-                </a:solidFill>
-                <a:latin typeface="Calibri" pitchFamily="34" charset="0"/>
-                <a:ea typeface="Calibri" pitchFamily="34" charset="-122"/>
-                <a:cs typeface="Calibri" pitchFamily="34" charset="-120"/>
-              </a:rPr>
-              <a:t>Cross-category comparison — silently degrades</a:t>
-            </a:r>
-            <a:endParaRPr lang="en-US" sz="1350" dirty="0"/>
-          </a:p>
-          <a:p>
-            <a:pPr marL="342900" indent="-342900">
+              <a:buNone/>
+            </a:pPr>
+            <a:r>
+              <a:rPr lang="en-US" sz="1450" b="1" dirty="0">
+                <a:solidFill>
+                  <a:srgbClr val="0B2545"/>
+                </a:solidFill>
+                <a:latin typeface="Calibri" pitchFamily="34" charset="0"/>
+                <a:ea typeface="Calibri" pitchFamily="34" charset="-122"/>
+                <a:cs typeface="Calibri" pitchFamily="34" charset="-120"/>
+              </a:rPr>
+              <a:t>Embeddings 504 ≠ CORS</a:t>
+            </a:r>
+            <a:endParaRPr lang="en-US" sz="1450" dirty="0"/>
+          </a:p>
+        </p:txBody>
+      </p:sp>
+      <p:sp>
+        <p:nvSpPr>
+          <p:cNvPr id="17" name="Text 12"/>
+          <p:cNvSpPr/>
+          <p:nvPr/>
+        </p:nvSpPr>
+        <p:spPr>
+          <a:xfrm>
+            <a:off x="8549640" y="2350008"/>
+            <a:ext cx="3145536" cy="1005840"/>
+          </a:xfrm>
+          <a:prstGeom prst="rect">
+            <a:avLst/>
+          </a:prstGeom>
+          <a:noFill/>
+          <a:ln/>
+        </p:spPr>
+        <p:txBody>
+          <a:bodyPr wrap="square" lIns="0" tIns="0" rIns="0" bIns="0" rtlCol="0" anchor="ctr"/>
+          <a:lstStyle/>
+          <a:p>
+            <a:pPr indent="0" marL="0">
               <a:lnSpc>
-                <a:spcPts val="2200"/>
+                <a:spcPts val="1450"/>
               </a:lnSpc>
-              <a:spcAft>
-                <a:spcPts val="1200"/>
-              </a:spcAft>
-              <a:buSzPct val="100000"/>
-              <a:buChar char="•"/>
-            </a:pPr>
-            <a:r>
-              <a:rPr lang="en-US" sz="1350" dirty="0">
-                <a:solidFill>
-                  <a:srgbClr val="1E293B"/>
-                </a:solidFill>
-                <a:latin typeface="Calibri" pitchFamily="34" charset="0"/>
-                <a:ea typeface="Calibri" pitchFamily="34" charset="-122"/>
-                <a:cs typeface="Calibri" pitchFamily="34" charset="-120"/>
-              </a:rPr>
-              <a:t>Unbounded cross-layer  — 413 error</a:t>
-            </a:r>
-            <a:endParaRPr lang="en-US" sz="1350" dirty="0"/>
-          </a:p>
-          <a:p>
-            <a:pPr marL="342900" indent="-342900">
+              <a:buNone/>
+            </a:pPr>
+            <a:r>
+              <a:rPr lang="en-US" sz="1150" dirty="0">
+                <a:solidFill>
+                  <a:srgbClr val="5B6B7F"/>
+                </a:solidFill>
+                <a:latin typeface="Calibri" pitchFamily="34" charset="0"/>
+                <a:ea typeface="Calibri" pitchFamily="34" charset="-122"/>
+                <a:cs typeface="Calibri" pitchFamily="34" charset="-120"/>
+              </a:rPr>
+              <a:t>Generic error looks like CORS but is a 504 timeout. Wide-schema reference layers trigger it; narrow ones succeed.</a:t>
+            </a:r>
+            <a:endParaRPr lang="en-US" sz="1150" dirty="0"/>
+          </a:p>
+        </p:txBody>
+      </p:sp>
+      <p:sp>
+        <p:nvSpPr>
+          <p:cNvPr id="18" name="Shape 13"/>
+          <p:cNvSpPr/>
+          <p:nvPr/>
+        </p:nvSpPr>
+        <p:spPr>
+          <a:xfrm>
+            <a:off x="502920" y="3749040"/>
+            <a:ext cx="3657600" cy="2148840"/>
+          </a:xfrm>
+          <a:prstGeom prst="roundRect">
+            <a:avLst>
+              <a:gd name="adj" fmla="val 3404"/>
+            </a:avLst>
+          </a:prstGeom>
+          <a:solidFill>
+            <a:srgbClr val="F4F7FA"/>
+          </a:solidFill>
+          <a:ln/>
+          <a:effectLst>
+            <a:outerShdw sx="100000" sy="100000" kx="0" ky="0" algn="bl" rotWithShape="0" blurRad="88900" dist="38100" dir="5400000">
+              <a:srgbClr val="000000">
+                <a:alpha val="12000"/>
+              </a:srgbClr>
+            </a:outerShdw>
+          </a:effectLst>
+        </p:spPr>
+      </p:sp>
+      <p:sp>
+        <p:nvSpPr>
+          <p:cNvPr id="19" name="Shape 14"/>
+          <p:cNvSpPr/>
+          <p:nvPr/>
+        </p:nvSpPr>
+        <p:spPr>
+          <a:xfrm>
+            <a:off x="758952" y="4005072"/>
+            <a:ext cx="713232" cy="713232"/>
+          </a:xfrm>
+          <a:prstGeom prst="ellipse">
+            <a:avLst/>
+          </a:prstGeom>
+          <a:solidFill>
+            <a:srgbClr val="E8A33D"/>
+          </a:solidFill>
+          <a:ln/>
+        </p:spPr>
+      </p:sp>
+      <p:pic>
+        <p:nvPicPr>
+          <p:cNvPr id="20" name="Image 3" descr="preencoded.png">    </p:cNvPr>
+          <p:cNvPicPr>
+            <a:picLocks noChangeAspect="1"/>
+          </p:cNvPicPr>
+          <p:nvPr/>
+        </p:nvPicPr>
+        <p:blipFill>
+          <a:blip r:embed="rId4"/>
+          <a:stretch>
+            <a:fillRect/>
+          </a:stretch>
+        </p:blipFill>
+        <p:spPr>
+          <a:xfrm>
+            <a:off x="944392" y="4190512"/>
+            <a:ext cx="342351" cy="342351"/>
+          </a:xfrm>
+          <a:prstGeom prst="rect">
+            <a:avLst/>
+          </a:prstGeom>
+        </p:spPr>
+      </p:pic>
+      <p:sp>
+        <p:nvSpPr>
+          <p:cNvPr id="21" name="Text 15"/>
+          <p:cNvSpPr/>
+          <p:nvPr/>
+        </p:nvSpPr>
+        <p:spPr>
+          <a:xfrm>
+            <a:off x="1600200" y="4023360"/>
+            <a:ext cx="2377440" cy="685800"/>
+          </a:xfrm>
+          <a:prstGeom prst="rect">
+            <a:avLst/>
+          </a:prstGeom>
+          <a:noFill/>
+          <a:ln/>
+        </p:spPr>
+        <p:txBody>
+          <a:bodyPr wrap="square" lIns="0" tIns="0" rIns="0" bIns="0" rtlCol="0" anchor="ctr"/>
+          <a:lstStyle/>
+          <a:p>
+            <a:pPr indent="0" marL="0">
               <a:lnSpc>
-                <a:spcPts val="2200"/>
+                <a:spcPts val="1600"/>
               </a:lnSpc>
-              <a:spcAft>
-                <a:spcPts val="1200"/>
-              </a:spcAft>
-              <a:buSzPct val="100000"/>
-              <a:buChar char="•"/>
-            </a:pPr>
-            <a:r>
-              <a:rPr lang="en-US" sz="1350" dirty="0">
-                <a:solidFill>
-                  <a:srgbClr val="1E293B"/>
-                </a:solidFill>
-                <a:latin typeface="Calibri" pitchFamily="34" charset="0"/>
-                <a:ea typeface="Calibri" pitchFamily="34" charset="-122"/>
-                <a:cs typeface="Calibri" pitchFamily="34" charset="-120"/>
-              </a:rPr>
-              <a:t>Broad sweeps  (vague, unscoped questions)</a:t>
-            </a:r>
-            <a:endParaRPr lang="en-US" sz="1350" dirty="0"/>
-          </a:p>
-          <a:p>
-            <a:pPr marL="342900" indent="-342900">
+              <a:buNone/>
+            </a:pPr>
+            <a:r>
+              <a:rPr lang="en-US" sz="1450" b="1" dirty="0">
+                <a:solidFill>
+                  <a:srgbClr val="0B2545"/>
+                </a:solidFill>
+                <a:latin typeface="Calibri" pitchFamily="34" charset="0"/>
+                <a:ea typeface="Calibri" pitchFamily="34" charset="-122"/>
+                <a:cs typeface="Calibri" pitchFamily="34" charset="-120"/>
+              </a:rPr>
+              <a:t>Cross-layer 413</a:t>
+            </a:r>
+            <a:endParaRPr lang="en-US" sz="1450" dirty="0"/>
+          </a:p>
+        </p:txBody>
+      </p:sp>
+      <p:sp>
+        <p:nvSpPr>
+          <p:cNvPr id="22" name="Text 16"/>
+          <p:cNvSpPr/>
+          <p:nvPr/>
+        </p:nvSpPr>
+        <p:spPr>
+          <a:xfrm>
+            <a:off x="758952" y="4773168"/>
+            <a:ext cx="3145536" cy="1005840"/>
+          </a:xfrm>
+          <a:prstGeom prst="rect">
+            <a:avLst/>
+          </a:prstGeom>
+          <a:noFill/>
+          <a:ln/>
+        </p:spPr>
+        <p:txBody>
+          <a:bodyPr wrap="square" lIns="0" tIns="0" rIns="0" bIns="0" rtlCol="0" anchor="ctr"/>
+          <a:lstStyle/>
+          <a:p>
+            <a:pPr indent="0" marL="0">
               <a:lnSpc>
-                <a:spcPts val="2200"/>
+                <a:spcPts val="1450"/>
               </a:lnSpc>
-              <a:spcAft>
-                <a:spcPts val="1200"/>
-              </a:spcAft>
-              <a:buSzPct val="100000"/>
-              <a:buChar char="•"/>
-            </a:pPr>
-            <a:r>
-              <a:rPr lang="en-US" sz="1350" dirty="0">
-                <a:solidFill>
-                  <a:srgbClr val="1E293B"/>
-                </a:solidFill>
-                <a:latin typeface="Calibri" pitchFamily="34" charset="0"/>
-                <a:ea typeface="Calibri" pitchFamily="34" charset="-122"/>
-                <a:cs typeface="Calibri" pitchFamily="34" charset="-120"/>
-              </a:rPr>
-              <a:t>Charts · forecasts · email · user location</a:t>
-            </a:r>
-            <a:endParaRPr lang="en-US" sz="1350" dirty="0"/>
-          </a:p>
-        </p:txBody>
-      </p:sp>
-      <p:sp>
-        <p:nvSpPr>
-          <p:cNvPr id="13" name="Text 9"/>
+              <a:buNone/>
+            </a:pPr>
+            <a:r>
+              <a:rPr lang="en-US" sz="1150" dirty="0">
+                <a:solidFill>
+                  <a:srgbClr val="5B6B7F"/>
+                </a:solidFill>
+                <a:latin typeface="Calibri" pitchFamily="34" charset="0"/>
+                <a:ea typeface="Calibri" pitchFamily="34" charset="-122"/>
+                <a:cs typeface="Calibri" pitchFamily="34" charset="-120"/>
+              </a:rPr>
+              <a:t>OOB agent submits national polygons as a spatial filter → 413. Fix: state-scope the prompt or pre-compute the attribute.</a:t>
+            </a:r>
+            <a:endParaRPr lang="en-US" sz="1150" dirty="0"/>
+          </a:p>
+        </p:txBody>
+      </p:sp>
+      <p:sp>
+        <p:nvSpPr>
+          <p:cNvPr id="23" name="Shape 17"/>
+          <p:cNvSpPr/>
+          <p:nvPr/>
+        </p:nvSpPr>
+        <p:spPr>
+          <a:xfrm>
+            <a:off x="4398264" y="3749040"/>
+            <a:ext cx="3657600" cy="2148840"/>
+          </a:xfrm>
+          <a:prstGeom prst="roundRect">
+            <a:avLst>
+              <a:gd name="adj" fmla="val 3404"/>
+            </a:avLst>
+          </a:prstGeom>
+          <a:solidFill>
+            <a:srgbClr val="F4F7FA"/>
+          </a:solidFill>
+          <a:ln/>
+          <a:effectLst>
+            <a:outerShdw sx="100000" sy="100000" kx="0" ky="0" algn="bl" rotWithShape="0" blurRad="88900" dist="38100" dir="5400000">
+              <a:srgbClr val="000000">
+                <a:alpha val="12000"/>
+              </a:srgbClr>
+            </a:outerShdw>
+          </a:effectLst>
+        </p:spPr>
+      </p:sp>
+      <p:sp>
+        <p:nvSpPr>
+          <p:cNvPr id="24" name="Shape 18"/>
+          <p:cNvSpPr/>
+          <p:nvPr/>
+        </p:nvSpPr>
+        <p:spPr>
+          <a:xfrm>
+            <a:off x="4654296" y="4005072"/>
+            <a:ext cx="713232" cy="713232"/>
+          </a:xfrm>
+          <a:prstGeom prst="ellipse">
+            <a:avLst/>
+          </a:prstGeom>
+          <a:solidFill>
+            <a:srgbClr val="E8A33D"/>
+          </a:solidFill>
+          <a:ln/>
+        </p:spPr>
+      </p:sp>
+      <p:pic>
+        <p:nvPicPr>
+          <p:cNvPr id="25" name="Image 4" descr="preencoded.png">    </p:cNvPr>
+          <p:cNvPicPr>
+            <a:picLocks noChangeAspect="1"/>
+          </p:cNvPicPr>
+          <p:nvPr/>
+        </p:nvPicPr>
+        <p:blipFill>
+          <a:blip r:embed="rId5"/>
+          <a:stretch>
+            <a:fillRect/>
+          </a:stretch>
+        </p:blipFill>
+        <p:spPr>
+          <a:xfrm>
+            <a:off x="4839736" y="4190512"/>
+            <a:ext cx="342351" cy="342351"/>
+          </a:xfrm>
+          <a:prstGeom prst="rect">
+            <a:avLst/>
+          </a:prstGeom>
+        </p:spPr>
+      </p:pic>
+      <p:sp>
+        <p:nvSpPr>
+          <p:cNvPr id="26" name="Text 19"/>
+          <p:cNvSpPr/>
+          <p:nvPr/>
+        </p:nvSpPr>
+        <p:spPr>
+          <a:xfrm>
+            <a:off x="5495544" y="4023360"/>
+            <a:ext cx="2377440" cy="685800"/>
+          </a:xfrm>
+          <a:prstGeom prst="rect">
+            <a:avLst/>
+          </a:prstGeom>
+          <a:noFill/>
+          <a:ln/>
+        </p:spPr>
+        <p:txBody>
+          <a:bodyPr wrap="square" lIns="0" tIns="0" rIns="0" bIns="0" rtlCol="0" anchor="ctr"/>
+          <a:lstStyle/>
+          <a:p>
+            <a:pPr indent="0" marL="0">
+              <a:lnSpc>
+                <a:spcPts val="1600"/>
+              </a:lnSpc>
+              <a:buNone/>
+            </a:pPr>
+            <a:r>
+              <a:rPr lang="en-US" sz="1450" b="1" dirty="0">
+                <a:solidFill>
+                  <a:srgbClr val="0B2545"/>
+                </a:solidFill>
+                <a:latin typeface="Calibri" pitchFamily="34" charset="0"/>
+                <a:ea typeface="Calibri" pitchFamily="34" charset="-122"/>
+                <a:cs typeface="Calibri" pitchFamily="34" charset="-120"/>
+              </a:rPr>
+              <a:t>Schema introspection lies</a:t>
+            </a:r>
+            <a:endParaRPr lang="en-US" sz="1450" dirty="0"/>
+          </a:p>
+        </p:txBody>
+      </p:sp>
+      <p:sp>
+        <p:nvSpPr>
+          <p:cNvPr id="27" name="Text 20"/>
+          <p:cNvSpPr/>
+          <p:nvPr/>
+        </p:nvSpPr>
+        <p:spPr>
+          <a:xfrm>
+            <a:off x="4654296" y="4773168"/>
+            <a:ext cx="3145536" cy="1005840"/>
+          </a:xfrm>
+          <a:prstGeom prst="rect">
+            <a:avLst/>
+          </a:prstGeom>
+          <a:noFill/>
+          <a:ln/>
+        </p:spPr>
+        <p:txBody>
+          <a:bodyPr wrap="square" lIns="0" tIns="0" rIns="0" bIns="0" rtlCol="0" anchor="ctr"/>
+          <a:lstStyle/>
+          <a:p>
+            <a:pPr indent="0" marL="0">
+              <a:lnSpc>
+                <a:spcPts val="1450"/>
+              </a:lnSpc>
+              <a:buNone/>
+            </a:pPr>
+            <a:r>
+              <a:rPr lang="en-US" sz="1150" dirty="0">
+                <a:solidFill>
+                  <a:srgbClr val="5B6B7F"/>
+                </a:solidFill>
+                <a:latin typeface="Calibri" pitchFamily="34" charset="0"/>
+                <a:ea typeface="Calibri" pitchFamily="34" charset="-122"/>
+                <a:cs typeface="Calibri" pitchFamily="34" charset="-120"/>
+              </a:rPr>
+              <a:t>"List fields" returned two contradictory lists in one turn. Verify schema via AGO Data → Fields — never the assistant.</a:t>
+            </a:r>
+            <a:endParaRPr lang="en-US" sz="1150" dirty="0"/>
+          </a:p>
+        </p:txBody>
+      </p:sp>
+      <p:sp>
+        <p:nvSpPr>
+          <p:cNvPr id="28" name="Shape 21"/>
+          <p:cNvSpPr/>
+          <p:nvPr/>
+        </p:nvSpPr>
+        <p:spPr>
+          <a:xfrm>
+            <a:off x="8293608" y="3749040"/>
+            <a:ext cx="3657600" cy="2148840"/>
+          </a:xfrm>
+          <a:prstGeom prst="roundRect">
+            <a:avLst>
+              <a:gd name="adj" fmla="val 3404"/>
+            </a:avLst>
+          </a:prstGeom>
+          <a:solidFill>
+            <a:srgbClr val="F4F7FA"/>
+          </a:solidFill>
+          <a:ln/>
+          <a:effectLst>
+            <a:outerShdw sx="100000" sy="100000" kx="0" ky="0" algn="bl" rotWithShape="0" blurRad="88900" dist="38100" dir="5400000">
+              <a:srgbClr val="000000">
+                <a:alpha val="12000"/>
+              </a:srgbClr>
+            </a:outerShdw>
+          </a:effectLst>
+        </p:spPr>
+      </p:sp>
+      <p:sp>
+        <p:nvSpPr>
+          <p:cNvPr id="29" name="Shape 22"/>
+          <p:cNvSpPr/>
+          <p:nvPr/>
+        </p:nvSpPr>
+        <p:spPr>
+          <a:xfrm>
+            <a:off x="8549640" y="4005072"/>
+            <a:ext cx="713232" cy="713232"/>
+          </a:xfrm>
+          <a:prstGeom prst="ellipse">
+            <a:avLst/>
+          </a:prstGeom>
+          <a:solidFill>
+            <a:srgbClr val="E8A33D"/>
+          </a:solidFill>
+          <a:ln/>
+        </p:spPr>
+      </p:sp>
+      <p:pic>
+        <p:nvPicPr>
+          <p:cNvPr id="30" name="Image 5" descr="preencoded.png">    </p:cNvPr>
+          <p:cNvPicPr>
+            <a:picLocks noChangeAspect="1"/>
+          </p:cNvPicPr>
+          <p:nvPr/>
+        </p:nvPicPr>
+        <p:blipFill>
+          <a:blip r:embed="rId6"/>
+          <a:stretch>
+            <a:fillRect/>
+          </a:stretch>
+        </p:blipFill>
+        <p:spPr>
+          <a:xfrm>
+            <a:off x="8735080" y="4190512"/>
+            <a:ext cx="342351" cy="342351"/>
+          </a:xfrm>
+          <a:prstGeom prst="rect">
+            <a:avLst/>
+          </a:prstGeom>
+        </p:spPr>
+      </p:pic>
+      <p:sp>
+        <p:nvSpPr>
+          <p:cNvPr id="31" name="Text 23"/>
+          <p:cNvSpPr/>
+          <p:nvPr/>
+        </p:nvSpPr>
+        <p:spPr>
+          <a:xfrm>
+            <a:off x="9390888" y="4023360"/>
+            <a:ext cx="2377440" cy="685800"/>
+          </a:xfrm>
+          <a:prstGeom prst="rect">
+            <a:avLst/>
+          </a:prstGeom>
+          <a:noFill/>
+          <a:ln/>
+        </p:spPr>
+        <p:txBody>
+          <a:bodyPr wrap="square" lIns="0" tIns="0" rIns="0" bIns="0" rtlCol="0" anchor="ctr"/>
+          <a:lstStyle/>
+          <a:p>
+            <a:pPr indent="0" marL="0">
+              <a:lnSpc>
+                <a:spcPts val="1600"/>
+              </a:lnSpc>
+              <a:buNone/>
+            </a:pPr>
+            <a:r>
+              <a:rPr lang="en-US" sz="1450" b="1" dirty="0">
+                <a:solidFill>
+                  <a:srgbClr val="0B2545"/>
+                </a:solidFill>
+                <a:latin typeface="Calibri" pitchFamily="34" charset="0"/>
+                <a:ea typeface="Calibri" pitchFamily="34" charset="-122"/>
+                <a:cs typeface="Calibri" pitchFamily="34" charset="-120"/>
+              </a:rPr>
+              <a:t>Verify, don't infer</a:t>
+            </a:r>
+            <a:endParaRPr lang="en-US" sz="1450" dirty="0"/>
+          </a:p>
+        </p:txBody>
+      </p:sp>
+      <p:sp>
+        <p:nvSpPr>
+          <p:cNvPr id="32" name="Text 24"/>
+          <p:cNvSpPr/>
+          <p:nvPr/>
+        </p:nvSpPr>
+        <p:spPr>
+          <a:xfrm>
+            <a:off x="8549640" y="4773168"/>
+            <a:ext cx="3145536" cy="1005840"/>
+          </a:xfrm>
+          <a:prstGeom prst="rect">
+            <a:avLst/>
+          </a:prstGeom>
+          <a:noFill/>
+          <a:ln/>
+        </p:spPr>
+        <p:txBody>
+          <a:bodyPr wrap="square" lIns="0" tIns="0" rIns="0" bIns="0" rtlCol="0" anchor="ctr"/>
+          <a:lstStyle/>
+          <a:p>
+            <a:pPr indent="0" marL="0">
+              <a:lnSpc>
+                <a:spcPts val="1450"/>
+              </a:lnSpc>
+              <a:buNone/>
+            </a:pPr>
+            <a:r>
+              <a:rPr lang="en-US" sz="1150" dirty="0">
+                <a:solidFill>
+                  <a:srgbClr val="5B6B7F"/>
+                </a:solidFill>
+                <a:latin typeface="Calibri" pitchFamily="34" charset="0"/>
+                <a:ea typeface="Calibri" pitchFamily="34" charset="-122"/>
+                <a:cs typeface="Calibri" pitchFamily="34" charset="-120"/>
+              </a:rPr>
+              <a:t>Filenames in dist/ aren't docs. We mounted a non-existent agent on a guess. Confirm against developers.arcgis.com.</a:t>
+            </a:r>
+            <a:endParaRPr lang="en-US" sz="1150" dirty="0"/>
+          </a:p>
+        </p:txBody>
+      </p:sp>
+      <p:sp>
+        <p:nvSpPr>
+          <p:cNvPr id="33" name="Text 25"/>
           <p:cNvSpPr/>
           <p:nvPr/>
         </p:nvSpPr>
@@ -8715,7 +9733,7 @@
       </p:sp>
       <p:sp>
         <p:nvSpPr>
-          <p:cNvPr id="14" name="Text 10"/>
+          <p:cNvPr id="34" name="Text 26"/>
           <p:cNvSpPr/>
           <p:nvPr/>
         </p:nvSpPr>
@@ -8809,7 +9827,7 @@
               <a:buNone/>
             </a:pPr>
             <a:r>
-              <a:rPr lang="en-US" sz="3000" b="1" dirty="0">
+              <a:rPr lang="en-US" sz="2800" b="1" dirty="0">
                 <a:solidFill>
                   <a:srgbClr val="0B2545"/>
                 </a:solidFill>
@@ -8817,69 +9835,30 @@
                 <a:ea typeface="Bookman Old Style" pitchFamily="34" charset="-122"/>
                 <a:cs typeface="Bookman Old Style" pitchFamily="34" charset="-120"/>
               </a:rPr>
-              <a:t>The demo run sheet — prompt shapes that work</a:t>
-            </a:r>
-            <a:endParaRPr lang="en-US" sz="3000" dirty="0"/>
-          </a:p>
-        </p:txBody>
-      </p:sp>
-      <p:sp>
-        <p:nvSpPr>
-          <p:cNvPr id="3" name="Text 1"/>
-          <p:cNvSpPr/>
-          <p:nvPr/>
-        </p:nvSpPr>
-        <p:spPr>
-          <a:xfrm>
-            <a:off x="502920" y="1078992"/>
-            <a:ext cx="10972800" cy="457200"/>
-          </a:xfrm>
-          <a:prstGeom prst="rect">
-            <a:avLst/>
-          </a:prstGeom>
-          <a:noFill/>
-          <a:ln/>
-        </p:spPr>
-        <p:txBody>
-          <a:bodyPr wrap="square" lIns="0" tIns="0" rIns="0" bIns="0" rtlCol="0" anchor="ctr"/>
-          <a:lstStyle/>
-          <a:p>
-            <a:pPr indent="0" marL="0">
-              <a:buNone/>
-            </a:pPr>
-            <a:r>
-              <a:rPr lang="en-US" sz="1400" dirty="0">
-                <a:solidFill>
-                  <a:srgbClr val="5B6B7F"/>
-                </a:solidFill>
-                <a:latin typeface="Calibri" pitchFamily="34" charset="0"/>
-                <a:ea typeface="Calibri" pitchFamily="34" charset="-122"/>
-                <a:cs typeface="Calibri" pitchFamily="34" charset="-120"/>
-              </a:rPr>
-              <a:t>Fill these with prompts you've verified against your data. Build from simple to the strongest hook.</a:t>
-            </a:r>
-            <a:endParaRPr lang="en-US" sz="1400" dirty="0"/>
-          </a:p>
-        </p:txBody>
-      </p:sp>
-      <p:sp>
-        <p:nvSpPr>
-          <p:cNvPr id="4" name="Shape 2"/>
-          <p:cNvSpPr/>
-          <p:nvPr/>
-        </p:nvSpPr>
-        <p:spPr>
-          <a:xfrm>
-            <a:off x="502920" y="1783080"/>
-            <a:ext cx="11201400" cy="932688"/>
+              <a:t>Prompt engineering: what the OOB agent can do</a:t>
+            </a:r>
+            <a:endParaRPr lang="en-US" sz="2800" dirty="0"/>
+          </a:p>
+        </p:txBody>
+      </p:sp>
+      <p:sp>
+        <p:nvSpPr>
+          <p:cNvPr id="3" name="Shape 1"/>
+          <p:cNvSpPr/>
+          <p:nvPr/>
+        </p:nvSpPr>
+        <p:spPr>
+          <a:xfrm>
+            <a:off x="502920" y="1371600"/>
+            <a:ext cx="5486400" cy="4572000"/>
           </a:xfrm>
           <a:prstGeom prst="roundRect">
             <a:avLst>
-              <a:gd name="adj" fmla="val 7843"/>
+              <a:gd name="adj" fmla="val 2000"/>
             </a:avLst>
           </a:prstGeom>
           <a:solidFill>
-            <a:srgbClr val="F4F7FA"/>
+            <a:srgbClr val="EAF4EF"/>
           </a:solidFill>
           <a:ln/>
           <a:effectLst>
@@ -8893,58 +9872,82 @@
       </p:sp>
       <p:sp>
         <p:nvSpPr>
-          <p:cNvPr id="5" name="Shape 3"/>
-          <p:cNvSpPr/>
-          <p:nvPr/>
-        </p:nvSpPr>
-        <p:spPr>
-          <a:xfrm>
-            <a:off x="731520" y="1984248"/>
-            <a:ext cx="566928" cy="566928"/>
+          <p:cNvPr id="4" name="Shape 2"/>
+          <p:cNvSpPr/>
+          <p:nvPr/>
+        </p:nvSpPr>
+        <p:spPr>
+          <a:xfrm>
+            <a:off x="822960" y="1645920"/>
+            <a:ext cx="731520" cy="731520"/>
           </a:xfrm>
           <a:prstGeom prst="ellipse">
             <a:avLst/>
           </a:prstGeom>
           <a:solidFill>
-            <a:srgbClr val="1C7293"/>
+            <a:srgbClr val="2A9D6F"/>
           </a:solidFill>
           <a:ln/>
         </p:spPr>
       </p:sp>
-      <p:sp>
-        <p:nvSpPr>
-          <p:cNvPr id="6" name="Text 4"/>
-          <p:cNvSpPr/>
-          <p:nvPr/>
-        </p:nvSpPr>
-        <p:spPr>
-          <a:xfrm>
-            <a:off x="731520" y="1984248"/>
-            <a:ext cx="566928" cy="566928"/>
-          </a:xfrm>
-          <a:prstGeom prst="rect">
-            <a:avLst/>
-          </a:prstGeom>
-          <a:noFill/>
-          <a:ln/>
-        </p:spPr>
-        <p:txBody>
-          <a:bodyPr wrap="square" lIns="0" tIns="0" rIns="0" bIns="0" rtlCol="0" anchor="ctr"/>
-          <a:lstStyle/>
-          <a:p>
-            <a:pPr algn="ctr" indent="0" marL="0">
+      <p:pic>
+        <p:nvPicPr>
+          <p:cNvPr id="5" name="Image 0" descr="preencoded.png">    </p:cNvPr>
+          <p:cNvPicPr>
+            <a:picLocks noChangeAspect="1"/>
+          </p:cNvPicPr>
+          <p:nvPr/>
+        </p:nvPicPr>
+        <p:blipFill>
+          <a:blip r:embed="rId1"/>
+          <a:stretch>
+            <a:fillRect/>
+          </a:stretch>
+        </p:blipFill>
+        <p:spPr>
+          <a:xfrm>
+            <a:off x="1013155" y="1836115"/>
+            <a:ext cx="351130" cy="351130"/>
+          </a:xfrm>
+          <a:prstGeom prst="rect">
+            <a:avLst/>
+          </a:prstGeom>
+        </p:spPr>
+      </p:pic>
+      <p:sp>
+        <p:nvSpPr>
+          <p:cNvPr id="6" name="Text 3"/>
+          <p:cNvSpPr/>
+          <p:nvPr/>
+        </p:nvSpPr>
+        <p:spPr>
+          <a:xfrm>
+            <a:off x="1691640" y="1645920"/>
+            <a:ext cx="4114800" cy="731520"/>
+          </a:xfrm>
+          <a:prstGeom prst="rect">
+            <a:avLst/>
+          </a:prstGeom>
+          <a:noFill/>
+          <a:ln/>
+        </p:spPr>
+        <p:txBody>
+          <a:bodyPr wrap="square" lIns="0" tIns="0" rIns="0" bIns="0" rtlCol="0" anchor="ctr"/>
+          <a:lstStyle/>
+          <a:p>
+            <a:pPr indent="0" marL="0">
               <a:buNone/>
             </a:pPr>
             <a:r>
               <a:rPr lang="en-US" sz="1800" b="1" dirty="0">
                 <a:solidFill>
-                  <a:srgbClr val="FFFFFF"/>
-                </a:solidFill>
-                <a:latin typeface="Calibri" pitchFamily="34" charset="0"/>
-                <a:ea typeface="Calibri" pitchFamily="34" charset="-122"/>
-                <a:cs typeface="Calibri" pitchFamily="34" charset="-120"/>
-              </a:rPr>
-              <a:t>1</a:t>
+                  <a:srgbClr val="2A9D6F"/>
+                </a:solidFill>
+                <a:latin typeface="Calibri" pitchFamily="34" charset="0"/>
+                <a:ea typeface="Calibri" pitchFamily="34" charset="-122"/>
+                <a:cs typeface="Calibri" pitchFamily="34" charset="-120"/>
+              </a:rPr>
+              <a:t>Reliable — demo these</a:t>
             </a:r>
             <a:endParaRPr lang="en-US" sz="1800" dirty="0"/>
           </a:p>
@@ -8952,100 +9955,164 @@
       </p:sp>
       <p:sp>
         <p:nvSpPr>
-          <p:cNvPr id="7" name="Text 5"/>
-          <p:cNvSpPr/>
-          <p:nvPr/>
-        </p:nvSpPr>
-        <p:spPr>
-          <a:xfrm>
-            <a:off x="1508760" y="1892808"/>
-            <a:ext cx="10058400" cy="438912"/>
-          </a:xfrm>
-          <a:prstGeom prst="rect">
-            <a:avLst/>
-          </a:prstGeom>
-          <a:noFill/>
-          <a:ln/>
-        </p:spPr>
-        <p:txBody>
-          <a:bodyPr wrap="square" lIns="0" tIns="0" rIns="0" bIns="0" rtlCol="0" anchor="ctr"/>
-          <a:lstStyle/>
-          <a:p>
-            <a:pPr indent="0" marL="0">
-              <a:buNone/>
-            </a:pPr>
-            <a:r>
-              <a:rPr lang="en-US" sz="1550" b="1" dirty="0">
-                <a:solidFill>
-                  <a:srgbClr val="0B2545"/>
-                </a:solidFill>
-                <a:latin typeface="Calibri" pitchFamily="34" charset="0"/>
-                <a:ea typeface="Calibri" pitchFamily="34" charset="-122"/>
-                <a:cs typeface="Calibri" pitchFamily="34" charset="-120"/>
-              </a:rPr>
-              <a:t>"Show me the &lt;high-priority&gt; &lt;records&gt;."</a:t>
-            </a:r>
-            <a:endParaRPr lang="en-US" sz="1550" dirty="0"/>
-          </a:p>
-        </p:txBody>
-      </p:sp>
-      <p:sp>
-        <p:nvSpPr>
-          <p:cNvPr id="8" name="Text 6"/>
-          <p:cNvSpPr/>
-          <p:nvPr/>
-        </p:nvSpPr>
-        <p:spPr>
-          <a:xfrm>
-            <a:off x="1508760" y="2286000"/>
-            <a:ext cx="10058400" cy="384048"/>
-          </a:xfrm>
-          <a:prstGeom prst="rect">
-            <a:avLst/>
-          </a:prstGeom>
-          <a:noFill/>
-          <a:ln/>
-        </p:spPr>
-        <p:txBody>
-          <a:bodyPr wrap="square" lIns="0" tIns="0" rIns="0" bIns="0" rtlCol="0" anchor="ctr"/>
-          <a:lstStyle/>
-          <a:p>
-            <a:pPr indent="0" marL="0">
-              <a:buNone/>
-            </a:pPr>
-            <a:r>
-              <a:rPr lang="en-US" sz="1250" dirty="0">
-                <a:solidFill>
-                  <a:srgbClr val="5B6B7F"/>
-                </a:solidFill>
-                <a:latin typeface="Calibri" pitchFamily="34" charset="0"/>
-                <a:ea typeface="Calibri" pitchFamily="34" charset="-122"/>
-                <a:cs typeface="Calibri" pitchFamily="34" charset="-120"/>
-              </a:rPr>
-              <a:t>Opener — single-attribute filter. Verify the count is stable.</a:t>
-            </a:r>
-            <a:endParaRPr lang="en-US" sz="1250" dirty="0"/>
-          </a:p>
-        </p:txBody>
-      </p:sp>
-      <p:sp>
-        <p:nvSpPr>
-          <p:cNvPr id="9" name="Shape 7"/>
-          <p:cNvSpPr/>
-          <p:nvPr/>
-        </p:nvSpPr>
-        <p:spPr>
-          <a:xfrm>
-            <a:off x="502920" y="2862072"/>
-            <a:ext cx="11201400" cy="932688"/>
+          <p:cNvPr id="7" name="Text 4"/>
+          <p:cNvSpPr/>
+          <p:nvPr/>
+        </p:nvSpPr>
+        <p:spPr>
+          <a:xfrm>
+            <a:off x="868680" y="2651760"/>
+            <a:ext cx="4937760" cy="3108960"/>
+          </a:xfrm>
+          <a:prstGeom prst="rect">
+            <a:avLst/>
+          </a:prstGeom>
+          <a:noFill/>
+          <a:ln/>
+        </p:spPr>
+        <p:txBody>
+          <a:bodyPr wrap="square" lIns="0" tIns="0" rIns="0" bIns="0" rtlCol="0" anchor="ctr"/>
+          <a:lstStyle/>
+          <a:p>
+            <a:pPr marL="342900" indent="-342900">
+              <a:lnSpc>
+                <a:spcPts val="2200"/>
+              </a:lnSpc>
+              <a:spcAft>
+                <a:spcPts val="1200"/>
+              </a:spcAft>
+              <a:buSzPct val="100000"/>
+              <a:buChar char="•"/>
+            </a:pPr>
+            <a:r>
+              <a:rPr lang="en-US" sz="1350" dirty="0">
+                <a:solidFill>
+                  <a:srgbClr val="1E293B"/>
+                </a:solidFill>
+                <a:latin typeface="Calibri" pitchFamily="34" charset="0"/>
+                <a:ea typeface="Calibri" pitchFamily="34" charset="-122"/>
+                <a:cs typeface="Calibri" pitchFamily="34" charset="-120"/>
+              </a:rPr>
+              <a:t>Attribute filters  ("show the high-priority records")</a:t>
+            </a:r>
+            <a:endParaRPr lang="en-US" sz="1350" dirty="0"/>
+          </a:p>
+          <a:p>
+            <a:pPr marL="342900" indent="-342900">
+              <a:lnSpc>
+                <a:spcPts val="2200"/>
+              </a:lnSpc>
+              <a:spcAft>
+                <a:spcPts val="1200"/>
+              </a:spcAft>
+              <a:buSzPct val="100000"/>
+              <a:buChar char="•"/>
+            </a:pPr>
+            <a:r>
+              <a:rPr lang="en-US" sz="1350" dirty="0">
+                <a:solidFill>
+                  <a:srgbClr val="1E293B"/>
+                </a:solidFill>
+                <a:latin typeface="Calibri" pitchFamily="34" charset="0"/>
+                <a:ea typeface="Calibri" pitchFamily="34" charset="-122"/>
+                <a:cs typeface="Calibri" pitchFamily="34" charset="-120"/>
+              </a:rPr>
+              <a:t>Single-group stats  ("average metric for a group")</a:t>
+            </a:r>
+            <a:endParaRPr lang="en-US" sz="1350" dirty="0"/>
+          </a:p>
+          <a:p>
+            <a:pPr marL="342900" indent="-342900">
+              <a:lnSpc>
+                <a:spcPts val="2200"/>
+              </a:lnSpc>
+              <a:spcAft>
+                <a:spcPts val="1200"/>
+              </a:spcAft>
+              <a:buSzPct val="100000"/>
+              <a:buChar char="•"/>
+            </a:pPr>
+            <a:r>
+              <a:rPr lang="en-US" sz="1350" dirty="0">
+                <a:solidFill>
+                  <a:srgbClr val="1E293B"/>
+                </a:solidFill>
+                <a:latin typeface="Calibri" pitchFamily="34" charset="0"/>
+                <a:ea typeface="Calibri" pitchFamily="34" charset="-122"/>
+                <a:cs typeface="Calibri" pitchFamily="34" charset="-120"/>
+              </a:rPr>
+              <a:t>Multi-attribute combos  (filter on two fields)</a:t>
+            </a:r>
+            <a:endParaRPr lang="en-US" sz="1350" dirty="0"/>
+          </a:p>
+          <a:p>
+            <a:pPr marL="342900" indent="-342900">
+              <a:lnSpc>
+                <a:spcPts val="2200"/>
+              </a:lnSpc>
+              <a:spcAft>
+                <a:spcPts val="1200"/>
+              </a:spcAft>
+              <a:buSzPct val="100000"/>
+              <a:buChar char="•"/>
+            </a:pPr>
+            <a:r>
+              <a:rPr lang="en-US" sz="1350" dirty="0">
+                <a:solidFill>
+                  <a:srgbClr val="1E293B"/>
+                </a:solidFill>
+                <a:latin typeface="Calibri" pitchFamily="34" charset="0"/>
+                <a:ea typeface="Calibri" pitchFamily="34" charset="-122"/>
+                <a:cs typeface="Calibri" pitchFamily="34" charset="-120"/>
+              </a:rPr>
+              <a:t>State / region-scoped cross-layer intersects</a:t>
+            </a:r>
+            <a:endParaRPr lang="en-US" sz="1350" dirty="0"/>
+          </a:p>
+          <a:p>
+            <a:pPr marL="342900" indent="-342900">
+              <a:lnSpc>
+                <a:spcPts val="2200"/>
+              </a:lnSpc>
+              <a:spcAft>
+                <a:spcPts val="1200"/>
+              </a:spcAft>
+              <a:buSzPct val="100000"/>
+              <a:buChar char="•"/>
+            </a:pPr>
+            <a:r>
+              <a:rPr lang="en-US" sz="1350" dirty="0">
+                <a:solidFill>
+                  <a:srgbClr val="1E293B"/>
+                </a:solidFill>
+                <a:latin typeface="Calibri" pitchFamily="34" charset="0"/>
+                <a:ea typeface="Calibri" pitchFamily="34" charset="-122"/>
+                <a:cs typeface="Calibri" pitchFamily="34" charset="-120"/>
+              </a:rPr>
+              <a:t>Pointed, single-subject questions</a:t>
+            </a:r>
+            <a:endParaRPr lang="en-US" sz="1350" dirty="0"/>
+          </a:p>
+        </p:txBody>
+      </p:sp>
+      <p:sp>
+        <p:nvSpPr>
+          <p:cNvPr id="8" name="Shape 5"/>
+          <p:cNvSpPr/>
+          <p:nvPr/>
+        </p:nvSpPr>
+        <p:spPr>
+          <a:xfrm>
+            <a:off x="6217920" y="1371600"/>
+            <a:ext cx="5486400" cy="4572000"/>
           </a:xfrm>
           <a:prstGeom prst="roundRect">
             <a:avLst>
-              <a:gd name="adj" fmla="val 7843"/>
+              <a:gd name="adj" fmla="val 2000"/>
             </a:avLst>
           </a:prstGeom>
           <a:solidFill>
-            <a:srgbClr val="F4F7FA"/>
+            <a:srgbClr val="FBEDEC"/>
           </a:solidFill>
           <a:ln/>
           <a:effectLst>
@@ -9059,58 +10126,82 @@
       </p:sp>
       <p:sp>
         <p:nvSpPr>
-          <p:cNvPr id="10" name="Shape 8"/>
-          <p:cNvSpPr/>
-          <p:nvPr/>
-        </p:nvSpPr>
-        <p:spPr>
-          <a:xfrm>
-            <a:off x="731520" y="3063240"/>
-            <a:ext cx="566928" cy="566928"/>
+          <p:cNvPr id="9" name="Shape 6"/>
+          <p:cNvSpPr/>
+          <p:nvPr/>
+        </p:nvSpPr>
+        <p:spPr>
+          <a:xfrm>
+            <a:off x="6537960" y="1645920"/>
+            <a:ext cx="731520" cy="731520"/>
           </a:xfrm>
           <a:prstGeom prst="ellipse">
             <a:avLst/>
           </a:prstGeom>
           <a:solidFill>
-            <a:srgbClr val="1C7293"/>
+            <a:srgbClr val="C24A45"/>
           </a:solidFill>
           <a:ln/>
         </p:spPr>
       </p:sp>
-      <p:sp>
-        <p:nvSpPr>
-          <p:cNvPr id="11" name="Text 9"/>
-          <p:cNvSpPr/>
-          <p:nvPr/>
-        </p:nvSpPr>
-        <p:spPr>
-          <a:xfrm>
-            <a:off x="731520" y="3063240"/>
-            <a:ext cx="566928" cy="566928"/>
-          </a:xfrm>
-          <a:prstGeom prst="rect">
-            <a:avLst/>
-          </a:prstGeom>
-          <a:noFill/>
-          <a:ln/>
-        </p:spPr>
-        <p:txBody>
-          <a:bodyPr wrap="square" lIns="0" tIns="0" rIns="0" bIns="0" rtlCol="0" anchor="ctr"/>
-          <a:lstStyle/>
-          <a:p>
-            <a:pPr algn="ctr" indent="0" marL="0">
+      <p:pic>
+        <p:nvPicPr>
+          <p:cNvPr id="10" name="Image 1" descr="preencoded.png">    </p:cNvPr>
+          <p:cNvPicPr>
+            <a:picLocks noChangeAspect="1"/>
+          </p:cNvPicPr>
+          <p:nvPr/>
+        </p:nvPicPr>
+        <p:blipFill>
+          <a:blip r:embed="rId2"/>
+          <a:stretch>
+            <a:fillRect/>
+          </a:stretch>
+        </p:blipFill>
+        <p:spPr>
+          <a:xfrm>
+            <a:off x="6728155" y="1836115"/>
+            <a:ext cx="351130" cy="351130"/>
+          </a:xfrm>
+          <a:prstGeom prst="rect">
+            <a:avLst/>
+          </a:prstGeom>
+        </p:spPr>
+      </p:pic>
+      <p:sp>
+        <p:nvSpPr>
+          <p:cNvPr id="11" name="Text 7"/>
+          <p:cNvSpPr/>
+          <p:nvPr/>
+        </p:nvSpPr>
+        <p:spPr>
+          <a:xfrm>
+            <a:off x="7406640" y="1645920"/>
+            <a:ext cx="4114800" cy="731520"/>
+          </a:xfrm>
+          <a:prstGeom prst="rect">
+            <a:avLst/>
+          </a:prstGeom>
+          <a:noFill/>
+          <a:ln/>
+        </p:spPr>
+        <p:txBody>
+          <a:bodyPr wrap="square" lIns="0" tIns="0" rIns="0" bIns="0" rtlCol="0" anchor="ctr"/>
+          <a:lstStyle/>
+          <a:p>
+            <a:pPr indent="0" marL="0">
               <a:buNone/>
             </a:pPr>
             <a:r>
               <a:rPr lang="en-US" sz="1800" b="1" dirty="0">
                 <a:solidFill>
-                  <a:srgbClr val="FFFFFF"/>
-                </a:solidFill>
-                <a:latin typeface="Calibri" pitchFamily="34" charset="0"/>
-                <a:ea typeface="Calibri" pitchFamily="34" charset="-122"/>
-                <a:cs typeface="Calibri" pitchFamily="34" charset="-120"/>
-              </a:rPr>
-              <a:t>2</a:t>
+                  <a:srgbClr val="C24A45"/>
+                </a:solidFill>
+                <a:latin typeface="Calibri" pitchFamily="34" charset="0"/>
+                <a:ea typeface="Calibri" pitchFamily="34" charset="-122"/>
+                <a:cs typeface="Calibri" pitchFamily="34" charset="-120"/>
+              </a:rPr>
+              <a:t>Fails / degrades — keep out</a:t>
             </a:r>
             <a:endParaRPr lang="en-US" sz="1800" dirty="0"/>
           </a:p>
@@ -9118,417 +10209,149 @@
       </p:sp>
       <p:sp>
         <p:nvSpPr>
-          <p:cNvPr id="12" name="Text 10"/>
-          <p:cNvSpPr/>
-          <p:nvPr/>
-        </p:nvSpPr>
-        <p:spPr>
-          <a:xfrm>
-            <a:off x="1508760" y="2971800"/>
-            <a:ext cx="10058400" cy="438912"/>
-          </a:xfrm>
-          <a:prstGeom prst="rect">
-            <a:avLst/>
-          </a:prstGeom>
-          <a:noFill/>
-          <a:ln/>
-        </p:spPr>
-        <p:txBody>
-          <a:bodyPr wrap="square" lIns="0" tIns="0" rIns="0" bIns="0" rtlCol="0" anchor="ctr"/>
-          <a:lstStyle/>
-          <a:p>
-            <a:pPr indent="0" marL="0">
-              <a:buNone/>
-            </a:pPr>
-            <a:r>
-              <a:rPr lang="en-US" sz="1550" b="1" dirty="0">
-                <a:solidFill>
-                  <a:srgbClr val="0B2545"/>
-                </a:solidFill>
-                <a:latin typeface="Calibri" pitchFamily="34" charset="0"/>
-                <a:ea typeface="Calibri" pitchFamily="34" charset="-122"/>
-                <a:cs typeface="Calibri" pitchFamily="34" charset="-120"/>
-              </a:rPr>
-              <a:t>"Average &lt;metric&gt; for &lt;one category&gt;?"</a:t>
-            </a:r>
-            <a:endParaRPr lang="en-US" sz="1550" dirty="0"/>
-          </a:p>
-        </p:txBody>
-      </p:sp>
-      <p:sp>
-        <p:nvSpPr>
-          <p:cNvPr id="13" name="Text 11"/>
-          <p:cNvSpPr/>
-          <p:nvPr/>
-        </p:nvSpPr>
-        <p:spPr>
-          <a:xfrm>
-            <a:off x="1508760" y="3364992"/>
-            <a:ext cx="10058400" cy="384048"/>
-          </a:xfrm>
-          <a:prstGeom prst="rect">
-            <a:avLst/>
-          </a:prstGeom>
-          <a:noFill/>
-          <a:ln/>
-        </p:spPr>
-        <p:txBody>
-          <a:bodyPr wrap="square" lIns="0" tIns="0" rIns="0" bIns="0" rtlCol="0" anchor="ctr"/>
-          <a:lstStyle/>
-          <a:p>
-            <a:pPr indent="0" marL="0">
-              <a:buNone/>
-            </a:pPr>
-            <a:r>
-              <a:rPr lang="en-US" sz="1250" dirty="0">
-                <a:solidFill>
-                  <a:srgbClr val="5B6B7F"/>
-                </a:solidFill>
-                <a:latin typeface="Calibri" pitchFamily="34" charset="0"/>
-                <a:ea typeface="Calibri" pitchFamily="34" charset="-122"/>
-                <a:cs typeface="Calibri" pitchFamily="34" charset="-120"/>
-              </a:rPr>
-              <a:t>Single-group stat. (Don't ask it to COMPARE two categories live.)</a:t>
-            </a:r>
-            <a:endParaRPr lang="en-US" sz="1250" dirty="0"/>
-          </a:p>
-        </p:txBody>
-      </p:sp>
-      <p:sp>
-        <p:nvSpPr>
-          <p:cNvPr id="14" name="Shape 12"/>
-          <p:cNvSpPr/>
-          <p:nvPr/>
-        </p:nvSpPr>
-        <p:spPr>
-          <a:xfrm>
-            <a:off x="502920" y="3941064"/>
-            <a:ext cx="11201400" cy="932688"/>
-          </a:xfrm>
-          <a:prstGeom prst="roundRect">
-            <a:avLst>
-              <a:gd name="adj" fmla="val 7843"/>
-            </a:avLst>
-          </a:prstGeom>
-          <a:solidFill>
-            <a:srgbClr val="F4F7FA"/>
-          </a:solidFill>
-          <a:ln/>
-          <a:effectLst>
-            <a:outerShdw sx="100000" sy="100000" kx="0" ky="0" algn="bl" rotWithShape="0" blurRad="88900" dist="38100" dir="5400000">
-              <a:srgbClr val="000000">
-                <a:alpha val="12000"/>
-              </a:srgbClr>
-            </a:outerShdw>
-          </a:effectLst>
-        </p:spPr>
-      </p:sp>
-      <p:sp>
-        <p:nvSpPr>
-          <p:cNvPr id="15" name="Shape 13"/>
-          <p:cNvSpPr/>
-          <p:nvPr/>
-        </p:nvSpPr>
-        <p:spPr>
-          <a:xfrm>
-            <a:off x="731520" y="4142232"/>
-            <a:ext cx="566928" cy="566928"/>
-          </a:xfrm>
-          <a:prstGeom prst="ellipse">
-            <a:avLst/>
-          </a:prstGeom>
-          <a:solidFill>
-            <a:srgbClr val="E8A33D"/>
-          </a:solidFill>
-          <a:ln/>
-        </p:spPr>
-      </p:sp>
-      <p:sp>
-        <p:nvSpPr>
-          <p:cNvPr id="16" name="Text 14"/>
-          <p:cNvSpPr/>
-          <p:nvPr/>
-        </p:nvSpPr>
-        <p:spPr>
-          <a:xfrm>
-            <a:off x="731520" y="4142232"/>
-            <a:ext cx="566928" cy="566928"/>
-          </a:xfrm>
-          <a:prstGeom prst="rect">
-            <a:avLst/>
-          </a:prstGeom>
-          <a:noFill/>
-          <a:ln/>
-        </p:spPr>
-        <p:txBody>
-          <a:bodyPr wrap="square" lIns="0" tIns="0" rIns="0" bIns="0" rtlCol="0" anchor="ctr"/>
-          <a:lstStyle/>
-          <a:p>
-            <a:pPr algn="ctr" indent="0" marL="0">
-              <a:buNone/>
-            </a:pPr>
-            <a:r>
-              <a:rPr lang="en-US" sz="1800" b="1" dirty="0">
-                <a:solidFill>
-                  <a:srgbClr val="FFFFFF"/>
-                </a:solidFill>
-                <a:latin typeface="Calibri" pitchFamily="34" charset="0"/>
-                <a:ea typeface="Calibri" pitchFamily="34" charset="-122"/>
-                <a:cs typeface="Calibri" pitchFamily="34" charset="-120"/>
-              </a:rPr>
-              <a:t>3</a:t>
-            </a:r>
-            <a:endParaRPr lang="en-US" sz="1800" dirty="0"/>
-          </a:p>
-        </p:txBody>
-      </p:sp>
-      <p:sp>
-        <p:nvSpPr>
-          <p:cNvPr id="17" name="Text 15"/>
-          <p:cNvSpPr/>
-          <p:nvPr/>
-        </p:nvSpPr>
-        <p:spPr>
-          <a:xfrm>
-            <a:off x="1508760" y="4050792"/>
-            <a:ext cx="10058400" cy="438912"/>
-          </a:xfrm>
-          <a:prstGeom prst="rect">
-            <a:avLst/>
-          </a:prstGeom>
-          <a:noFill/>
-          <a:ln/>
-        </p:spPr>
-        <p:txBody>
-          <a:bodyPr wrap="square" lIns="0" tIns="0" rIns="0" bIns="0" rtlCol="0" anchor="ctr"/>
-          <a:lstStyle/>
-          <a:p>
-            <a:pPr indent="0" marL="0">
-              <a:buNone/>
-            </a:pPr>
-            <a:r>
-              <a:rPr lang="en-US" sz="1550" b="1" dirty="0">
-                <a:solidFill>
-                  <a:srgbClr val="0B2545"/>
-                </a:solidFill>
-                <a:latin typeface="Calibri" pitchFamily="34" charset="0"/>
-                <a:ea typeface="Calibri" pitchFamily="34" charset="-122"/>
-                <a:cs typeface="Calibri" pitchFamily="34" charset="-120"/>
-              </a:rPr>
-              <a:t>"Which &lt;high-priority&gt; &lt;records&gt; also &lt;2nd condition&gt;?"</a:t>
-            </a:r>
-            <a:endParaRPr lang="en-US" sz="1550" dirty="0"/>
-          </a:p>
-        </p:txBody>
-      </p:sp>
-      <p:sp>
-        <p:nvSpPr>
-          <p:cNvPr id="18" name="Text 16"/>
-          <p:cNvSpPr/>
-          <p:nvPr/>
-        </p:nvSpPr>
-        <p:spPr>
-          <a:xfrm>
-            <a:off x="1508760" y="4443984"/>
-            <a:ext cx="10058400" cy="384048"/>
-          </a:xfrm>
-          <a:prstGeom prst="rect">
-            <a:avLst/>
-          </a:prstGeom>
-          <a:noFill/>
-          <a:ln/>
-        </p:spPr>
-        <p:txBody>
-          <a:bodyPr wrap="square" lIns="0" tIns="0" rIns="0" bIns="0" rtlCol="0" anchor="ctr"/>
-          <a:lstStyle/>
-          <a:p>
-            <a:pPr indent="0" marL="0">
-              <a:buNone/>
-            </a:pPr>
-            <a:r>
-              <a:rPr lang="en-US" sz="1250" dirty="0">
-                <a:solidFill>
-                  <a:srgbClr val="5B6B7F"/>
-                </a:solidFill>
-                <a:latin typeface="Calibri" pitchFamily="34" charset="0"/>
-                <a:ea typeface="Calibri" pitchFamily="34" charset="-122"/>
-                <a:cs typeface="Calibri" pitchFamily="34" charset="-120"/>
-              </a:rPr>
-              <a:t>Centerpiece — a multi-attribute insight with a clear takeaway.</a:t>
-            </a:r>
-            <a:endParaRPr lang="en-US" sz="1250" dirty="0"/>
-          </a:p>
-        </p:txBody>
-      </p:sp>
-      <p:sp>
-        <p:nvSpPr>
-          <p:cNvPr id="19" name="Shape 17"/>
-          <p:cNvSpPr/>
-          <p:nvPr/>
-        </p:nvSpPr>
-        <p:spPr>
-          <a:xfrm>
-            <a:off x="502920" y="5020056"/>
-            <a:ext cx="11201400" cy="932688"/>
-          </a:xfrm>
-          <a:prstGeom prst="roundRect">
-            <a:avLst>
-              <a:gd name="adj" fmla="val 7843"/>
-            </a:avLst>
-          </a:prstGeom>
-          <a:solidFill>
-            <a:srgbClr val="F4F7FA"/>
-          </a:solidFill>
-          <a:ln/>
-          <a:effectLst>
-            <a:outerShdw sx="100000" sy="100000" kx="0" ky="0" algn="bl" rotWithShape="0" blurRad="88900" dist="38100" dir="5400000">
-              <a:srgbClr val="000000">
-                <a:alpha val="12000"/>
-              </a:srgbClr>
-            </a:outerShdw>
-          </a:effectLst>
-        </p:spPr>
-      </p:sp>
-      <p:sp>
-        <p:nvSpPr>
-          <p:cNvPr id="20" name="Shape 18"/>
-          <p:cNvSpPr/>
-          <p:nvPr/>
-        </p:nvSpPr>
-        <p:spPr>
-          <a:xfrm>
-            <a:off x="731520" y="5221224"/>
-            <a:ext cx="566928" cy="566928"/>
-          </a:xfrm>
-          <a:prstGeom prst="ellipse">
-            <a:avLst/>
-          </a:prstGeom>
-          <a:solidFill>
-            <a:srgbClr val="0B2545"/>
-          </a:solidFill>
-          <a:ln/>
-        </p:spPr>
-      </p:sp>
-      <p:sp>
-        <p:nvSpPr>
-          <p:cNvPr id="21" name="Text 19"/>
-          <p:cNvSpPr/>
-          <p:nvPr/>
-        </p:nvSpPr>
-        <p:spPr>
-          <a:xfrm>
-            <a:off x="731520" y="5221224"/>
-            <a:ext cx="566928" cy="566928"/>
-          </a:xfrm>
-          <a:prstGeom prst="rect">
-            <a:avLst/>
-          </a:prstGeom>
-          <a:noFill/>
-          <a:ln/>
-        </p:spPr>
-        <p:txBody>
-          <a:bodyPr wrap="square" lIns="0" tIns="0" rIns="0" bIns="0" rtlCol="0" anchor="ctr"/>
-          <a:lstStyle/>
-          <a:p>
-            <a:pPr algn="ctr" indent="0" marL="0">
-              <a:buNone/>
-            </a:pPr>
-            <a:r>
-              <a:rPr lang="en-US" sz="1800" b="1" dirty="0">
-                <a:solidFill>
-                  <a:srgbClr val="FFFFFF"/>
-                </a:solidFill>
-                <a:latin typeface="Calibri" pitchFamily="34" charset="0"/>
-                <a:ea typeface="Calibri" pitchFamily="34" charset="-122"/>
-                <a:cs typeface="Calibri" pitchFamily="34" charset="-120"/>
-              </a:rPr>
-              <a:t>4</a:t>
-            </a:r>
-            <a:endParaRPr lang="en-US" sz="1800" dirty="0"/>
-          </a:p>
-        </p:txBody>
-      </p:sp>
-      <p:sp>
-        <p:nvSpPr>
-          <p:cNvPr id="22" name="Text 20"/>
-          <p:cNvSpPr/>
-          <p:nvPr/>
-        </p:nvSpPr>
-        <p:spPr>
-          <a:xfrm>
-            <a:off x="1508760" y="5129784"/>
-            <a:ext cx="10058400" cy="438912"/>
-          </a:xfrm>
-          <a:prstGeom prst="rect">
-            <a:avLst/>
-          </a:prstGeom>
-          <a:noFill/>
-          <a:ln/>
-        </p:spPr>
-        <p:txBody>
-          <a:bodyPr wrap="square" lIns="0" tIns="0" rIns="0" bIns="0" rtlCol="0" anchor="ctr"/>
-          <a:lstStyle/>
-          <a:p>
-            <a:pPr indent="0" marL="0">
-              <a:buNone/>
-            </a:pPr>
-            <a:r>
-              <a:rPr lang="en-US" sz="1550" b="1" dirty="0">
-                <a:solidFill>
-                  <a:srgbClr val="0B2545"/>
-                </a:solidFill>
-                <a:latin typeface="Calibri" pitchFamily="34" charset="0"/>
-                <a:ea typeface="Calibri" pitchFamily="34" charset="-122"/>
-                <a:cs typeface="Calibri" pitchFamily="34" charset="-120"/>
-              </a:rPr>
-              <a:t>"Which &lt;records&gt; in &lt;region&gt; intersect &lt;layer&gt;?"</a:t>
-            </a:r>
-            <a:endParaRPr lang="en-US" sz="1550" dirty="0"/>
-          </a:p>
-        </p:txBody>
-      </p:sp>
-      <p:sp>
-        <p:nvSpPr>
-          <p:cNvPr id="23" name="Text 21"/>
-          <p:cNvSpPr/>
-          <p:nvPr/>
-        </p:nvSpPr>
-        <p:spPr>
-          <a:xfrm>
-            <a:off x="1508760" y="5522976"/>
-            <a:ext cx="10058400" cy="384048"/>
-          </a:xfrm>
-          <a:prstGeom prst="rect">
-            <a:avLst/>
-          </a:prstGeom>
-          <a:noFill/>
-          <a:ln/>
-        </p:spPr>
-        <p:txBody>
-          <a:bodyPr wrap="square" lIns="0" tIns="0" rIns="0" bIns="0" rtlCol="0" anchor="ctr"/>
-          <a:lstStyle/>
-          <a:p>
-            <a:pPr indent="0" marL="0">
-              <a:buNone/>
-            </a:pPr>
-            <a:r>
-              <a:rPr lang="en-US" sz="1250" dirty="0">
-                <a:solidFill>
-                  <a:srgbClr val="5B6B7F"/>
-                </a:solidFill>
-                <a:latin typeface="Calibri" pitchFamily="34" charset="0"/>
-                <a:ea typeface="Calibri" pitchFamily="34" charset="-122"/>
-                <a:cs typeface="Calibri" pitchFamily="34" charset="-120"/>
-              </a:rPr>
-              <a:t>Cross-layer reveal — must stay region-scoped (else 413).</a:t>
-            </a:r>
-            <a:endParaRPr lang="en-US" sz="1250" dirty="0"/>
-          </a:p>
-        </p:txBody>
-      </p:sp>
-      <p:sp>
-        <p:nvSpPr>
-          <p:cNvPr id="24" name="Text 22"/>
+          <p:cNvPr id="12" name="Text 8"/>
+          <p:cNvSpPr/>
+          <p:nvPr/>
+        </p:nvSpPr>
+        <p:spPr>
+          <a:xfrm>
+            <a:off x="6583680" y="2651760"/>
+            <a:ext cx="4937760" cy="3108960"/>
+          </a:xfrm>
+          <a:prstGeom prst="rect">
+            <a:avLst/>
+          </a:prstGeom>
+          <a:noFill/>
+          <a:ln/>
+        </p:spPr>
+        <p:txBody>
+          <a:bodyPr wrap="square" lIns="0" tIns="0" rIns="0" bIns="0" rtlCol="0" anchor="ctr"/>
+          <a:lstStyle/>
+          <a:p>
+            <a:pPr marL="342900" indent="-342900">
+              <a:lnSpc>
+                <a:spcPts val="2200"/>
+              </a:lnSpc>
+              <a:spcAft>
+                <a:spcPts val="1200"/>
+              </a:spcAft>
+              <a:buSzPct val="100000"/>
+              <a:buChar char="•"/>
+            </a:pPr>
+            <a:r>
+              <a:rPr lang="en-US" sz="1350" dirty="0">
+                <a:solidFill>
+                  <a:srgbClr val="1E293B"/>
+                </a:solidFill>
+                <a:latin typeface="Calibri" pitchFamily="34" charset="0"/>
+                <a:ea typeface="Calibri" pitchFamily="34" charset="-122"/>
+                <a:cs typeface="Calibri" pitchFamily="34" charset="-120"/>
+              </a:rPr>
+              <a:t>Schema introspection  ("list fields") — hallucinates</a:t>
+            </a:r>
+            <a:endParaRPr lang="en-US" sz="1350" dirty="0"/>
+          </a:p>
+          <a:p>
+            <a:pPr marL="342900" indent="-342900">
+              <a:lnSpc>
+                <a:spcPts val="2200"/>
+              </a:lnSpc>
+              <a:spcAft>
+                <a:spcPts val="1200"/>
+              </a:spcAft>
+              <a:buSzPct val="100000"/>
+              <a:buChar char="•"/>
+            </a:pPr>
+            <a:r>
+              <a:rPr lang="en-US" sz="1350" dirty="0">
+                <a:solidFill>
+                  <a:srgbClr val="1E293B"/>
+                </a:solidFill>
+                <a:latin typeface="Calibri" pitchFamily="34" charset="0"/>
+                <a:ea typeface="Calibri" pitchFamily="34" charset="-122"/>
+                <a:cs typeface="Calibri" pitchFamily="34" charset="-120"/>
+              </a:rPr>
+              <a:t>Cross-category comparison — silently degrades</a:t>
+            </a:r>
+            <a:endParaRPr lang="en-US" sz="1350" dirty="0"/>
+          </a:p>
+          <a:p>
+            <a:pPr marL="342900" indent="-342900">
+              <a:lnSpc>
+                <a:spcPts val="2200"/>
+              </a:lnSpc>
+              <a:spcAft>
+                <a:spcPts val="1200"/>
+              </a:spcAft>
+              <a:buSzPct val="100000"/>
+              <a:buChar char="•"/>
+            </a:pPr>
+            <a:r>
+              <a:rPr lang="en-US" sz="1350" dirty="0">
+                <a:solidFill>
+                  <a:srgbClr val="1E293B"/>
+                </a:solidFill>
+                <a:latin typeface="Calibri" pitchFamily="34" charset="0"/>
+                <a:ea typeface="Calibri" pitchFamily="34" charset="-122"/>
+                <a:cs typeface="Calibri" pitchFamily="34" charset="-120"/>
+              </a:rPr>
+              <a:t>Unbounded cross-layer  — 413 error</a:t>
+            </a:r>
+            <a:endParaRPr lang="en-US" sz="1350" dirty="0"/>
+          </a:p>
+          <a:p>
+            <a:pPr marL="342900" indent="-342900">
+              <a:lnSpc>
+                <a:spcPts val="2200"/>
+              </a:lnSpc>
+              <a:spcAft>
+                <a:spcPts val="1200"/>
+              </a:spcAft>
+              <a:buSzPct val="100000"/>
+              <a:buChar char="•"/>
+            </a:pPr>
+            <a:r>
+              <a:rPr lang="en-US" sz="1350" dirty="0">
+                <a:solidFill>
+                  <a:srgbClr val="1E293B"/>
+                </a:solidFill>
+                <a:latin typeface="Calibri" pitchFamily="34" charset="0"/>
+                <a:ea typeface="Calibri" pitchFamily="34" charset="-122"/>
+                <a:cs typeface="Calibri" pitchFamily="34" charset="-120"/>
+              </a:rPr>
+              <a:t>Broad sweeps  (vague, unscoped questions)</a:t>
+            </a:r>
+            <a:endParaRPr lang="en-US" sz="1350" dirty="0"/>
+          </a:p>
+          <a:p>
+            <a:pPr marL="342900" indent="-342900">
+              <a:lnSpc>
+                <a:spcPts val="2200"/>
+              </a:lnSpc>
+              <a:spcAft>
+                <a:spcPts val="1200"/>
+              </a:spcAft>
+              <a:buSzPct val="100000"/>
+              <a:buChar char="•"/>
+            </a:pPr>
+            <a:r>
+              <a:rPr lang="en-US" sz="1350" dirty="0">
+                <a:solidFill>
+                  <a:srgbClr val="1E293B"/>
+                </a:solidFill>
+                <a:latin typeface="Calibri" pitchFamily="34" charset="0"/>
+                <a:ea typeface="Calibri" pitchFamily="34" charset="-122"/>
+                <a:cs typeface="Calibri" pitchFamily="34" charset="-120"/>
+              </a:rPr>
+              <a:t>Charts · forecasts · email · user location</a:t>
+            </a:r>
+            <a:endParaRPr lang="en-US" sz="1350" dirty="0"/>
+          </a:p>
+        </p:txBody>
+      </p:sp>
+      <p:sp>
+        <p:nvSpPr>
+          <p:cNvPr id="13" name="Text 9"/>
           <p:cNvSpPr/>
           <p:nvPr/>
         </p:nvSpPr>
@@ -9567,7 +10390,7 @@
       </p:sp>
       <p:sp>
         <p:nvSpPr>
-          <p:cNvPr id="25" name="Text 23"/>
+          <p:cNvPr id="14" name="Text 10"/>
           <p:cNvSpPr/>
           <p:nvPr/>
         </p:nvSpPr>

</xml_diff>